<commit_message>
Re-tone all visuals to Teal Mono (logo, banner, slides, deck, poster, demo)
</commit_message>
<xml_diff>
--- a/docs/speccord-deck.pptx
+++ b/docs/speccord-deck.pptx
@@ -3092,7 +3092,7 @@
     <p:bg>
       <p:bgPr>
         <a:solidFill>
-          <a:srgbClr val="0F172A"/>
+          <a:srgbClr val="07171A"/>
         </a:solidFill>
         <a:effectLst/>
       </p:bgPr>
@@ -3119,7 +3119,7 @@
             <a:avLst/>
           </a:prstGeom>
           <a:solidFill>
-            <a:srgbClr val="38BDF8"/>
+            <a:srgbClr val="22D3EE"/>
           </a:solidFill>
           <a:ln>
             <a:noFill/>
@@ -3163,7 +3163,7 @@
             <a:avLst/>
           </a:prstGeom>
           <a:solidFill>
-            <a:srgbClr val="34D399"/>
+            <a:srgbClr val="2DD4BF"/>
           </a:solidFill>
           <a:ln>
             <a:noFill/>
@@ -3207,7 +3207,7 @@
             <a:avLst/>
           </a:prstGeom>
           <a:solidFill>
-            <a:srgbClr val="A78BFA"/>
+            <a:srgbClr val="5EEAD4"/>
           </a:solidFill>
           <a:ln>
             <a:noFill/>
@@ -3262,7 +3262,7 @@
             <a:r>
               <a:rPr sz="9600" b="1">
                 <a:solidFill>
-                  <a:srgbClr val="E2E8F0"/>
+                  <a:srgbClr val="D6EEF0"/>
                 </a:solidFill>
                 <a:latin typeface="Helvetica Neue"/>
               </a:rPr>
@@ -3297,7 +3297,7 @@
             <a:r>
               <a:rPr sz="2200" b="0">
                 <a:solidFill>
-                  <a:srgbClr val="38BDF8"/>
+                  <a:srgbClr val="22D3EE"/>
                 </a:solidFill>
                 <a:latin typeface="Helvetica Neue"/>
               </a:rPr>
@@ -3332,7 +3332,7 @@
             <a:r>
               <a:rPr sz="1800" b="0">
                 <a:solidFill>
-                  <a:srgbClr val="94A3B8"/>
+                  <a:srgbClr val="8FB2B6"/>
                 </a:solidFill>
                 <a:latin typeface="Helvetica Neue"/>
               </a:rPr>
@@ -3356,11 +3356,11 @@
             <a:avLst/>
           </a:prstGeom>
           <a:solidFill>
-            <a:srgbClr val="0F172A"/>
+            <a:srgbClr val="07171A"/>
           </a:solidFill>
           <a:ln w="25400">
             <a:solidFill>
-              <a:srgbClr val="38BDF8"/>
+              <a:srgbClr val="22D3EE"/>
             </a:solidFill>
           </a:ln>
           <a:effectLst/>
@@ -3413,7 +3413,7 @@
             <a:r>
               <a:rPr sz="1500" b="1">
                 <a:solidFill>
-                  <a:srgbClr val="38BDF8"/>
+                  <a:srgbClr val="22D3EE"/>
                 </a:solidFill>
                 <a:latin typeface="Helvetica Neue"/>
               </a:rPr>
@@ -3437,11 +3437,11 @@
             <a:avLst/>
           </a:prstGeom>
           <a:solidFill>
-            <a:srgbClr val="0F172A"/>
+            <a:srgbClr val="07171A"/>
           </a:solidFill>
           <a:ln w="25400">
             <a:solidFill>
-              <a:srgbClr val="34D399"/>
+              <a:srgbClr val="2DD4BF"/>
             </a:solidFill>
           </a:ln>
           <a:effectLst/>
@@ -3494,7 +3494,7 @@
             <a:r>
               <a:rPr sz="1500" b="1">
                 <a:solidFill>
-                  <a:srgbClr val="34D399"/>
+                  <a:srgbClr val="2DD4BF"/>
                 </a:solidFill>
                 <a:latin typeface="Helvetica Neue"/>
               </a:rPr>
@@ -3518,11 +3518,11 @@
             <a:avLst/>
           </a:prstGeom>
           <a:solidFill>
-            <a:srgbClr val="0F172A"/>
+            <a:srgbClr val="07171A"/>
           </a:solidFill>
           <a:ln w="25400">
             <a:solidFill>
-              <a:srgbClr val="A78BFA"/>
+              <a:srgbClr val="5EEAD4"/>
             </a:solidFill>
           </a:ln>
           <a:effectLst/>
@@ -3575,7 +3575,7 @@
             <a:r>
               <a:rPr sz="1500" b="1">
                 <a:solidFill>
-                  <a:srgbClr val="A78BFA"/>
+                  <a:srgbClr val="5EEAD4"/>
                 </a:solidFill>
                 <a:latin typeface="Helvetica Neue"/>
               </a:rPr>
@@ -3610,7 +3610,7 @@
             <a:r>
               <a:rPr sz="1300" b="1">
                 <a:solidFill>
-                  <a:srgbClr val="94A3B8"/>
+                  <a:srgbClr val="8FB2B6"/>
                 </a:solidFill>
                 <a:latin typeface="Helvetica Neue"/>
               </a:rPr>
@@ -3645,7 +3645,7 @@
             <a:r>
               <a:rPr sz="1300" b="0">
                 <a:solidFill>
-                  <a:srgbClr val="94A3B8"/>
+                  <a:srgbClr val="8FB2B6"/>
                 </a:solidFill>
                 <a:latin typeface="Helvetica Neue"/>
               </a:rPr>
@@ -3668,7 +3668,7 @@
     <p:bg>
       <p:bgPr>
         <a:solidFill>
-          <a:srgbClr val="0F172A"/>
+          <a:srgbClr val="07171A"/>
         </a:solidFill>
         <a:effectLst/>
       </p:bgPr>
@@ -3695,7 +3695,7 @@
             <a:avLst/>
           </a:prstGeom>
           <a:solidFill>
-            <a:srgbClr val="38BDF8"/>
+            <a:srgbClr val="22D3EE"/>
           </a:solidFill>
           <a:ln>
             <a:noFill/>
@@ -3750,7 +3750,7 @@
             <a:r>
               <a:rPr sz="1500" b="1">
                 <a:solidFill>
-                  <a:srgbClr val="38BDF8"/>
+                  <a:srgbClr val="22D3EE"/>
                 </a:solidFill>
                 <a:latin typeface="Helvetica Neue"/>
               </a:rPr>
@@ -3785,7 +3785,7 @@
             <a:r>
               <a:rPr sz="3400" b="1">
                 <a:solidFill>
-                  <a:srgbClr val="E2E8F0"/>
+                  <a:srgbClr val="D6EEF0"/>
                 </a:solidFill>
                 <a:latin typeface="Helvetica Neue"/>
               </a:rPr>
@@ -3809,7 +3809,7 @@
             <a:avLst/>
           </a:prstGeom>
           <a:solidFill>
-            <a:srgbClr val="1E293B"/>
+            <a:srgbClr val="0F242A"/>
           </a:solidFill>
           <a:ln>
             <a:noFill/>
@@ -3853,7 +3853,7 @@
             <a:avLst/>
           </a:prstGeom>
           <a:solidFill>
-            <a:srgbClr val="38BDF8"/>
+            <a:srgbClr val="22D3EE"/>
           </a:solidFill>
           <a:ln>
             <a:noFill/>
@@ -3908,7 +3908,7 @@
             <a:r>
               <a:rPr sz="2000" b="1">
                 <a:solidFill>
-                  <a:srgbClr val="38BDF8"/>
+                  <a:srgbClr val="22D3EE"/>
                 </a:solidFill>
                 <a:latin typeface="Helvetica Neue"/>
               </a:rPr>
@@ -3943,7 +3943,7 @@
             <a:r>
               <a:rPr sz="1500" b="0">
                 <a:solidFill>
-                  <a:srgbClr val="94A3B8"/>
+                  <a:srgbClr val="8FB2B6"/>
                 </a:solidFill>
                 <a:latin typeface="Helvetica Neue"/>
               </a:rPr>
@@ -3967,7 +3967,7 @@
             <a:avLst/>
           </a:prstGeom>
           <a:solidFill>
-            <a:srgbClr val="1E293B"/>
+            <a:srgbClr val="0F242A"/>
           </a:solidFill>
           <a:ln>
             <a:noFill/>
@@ -4011,7 +4011,7 @@
             <a:avLst/>
           </a:prstGeom>
           <a:solidFill>
-            <a:srgbClr val="34D399"/>
+            <a:srgbClr val="2DD4BF"/>
           </a:solidFill>
           <a:ln>
             <a:noFill/>
@@ -4066,7 +4066,7 @@
             <a:r>
               <a:rPr sz="2000" b="1">
                 <a:solidFill>
-                  <a:srgbClr val="34D399"/>
+                  <a:srgbClr val="2DD4BF"/>
                 </a:solidFill>
                 <a:latin typeface="Helvetica Neue"/>
               </a:rPr>
@@ -4101,7 +4101,7 @@
             <a:r>
               <a:rPr sz="1500" b="0">
                 <a:solidFill>
-                  <a:srgbClr val="94A3B8"/>
+                  <a:srgbClr val="8FB2B6"/>
                 </a:solidFill>
                 <a:latin typeface="Helvetica Neue"/>
               </a:rPr>
@@ -4125,7 +4125,7 @@
             <a:avLst/>
           </a:prstGeom>
           <a:solidFill>
-            <a:srgbClr val="1E293B"/>
+            <a:srgbClr val="0F242A"/>
           </a:solidFill>
           <a:ln>
             <a:noFill/>
@@ -4169,7 +4169,7 @@
             <a:avLst/>
           </a:prstGeom>
           <a:solidFill>
-            <a:srgbClr val="A78BFA"/>
+            <a:srgbClr val="5EEAD4"/>
           </a:solidFill>
           <a:ln>
             <a:noFill/>
@@ -4224,7 +4224,7 @@
             <a:r>
               <a:rPr sz="2000" b="1">
                 <a:solidFill>
-                  <a:srgbClr val="A78BFA"/>
+                  <a:srgbClr val="5EEAD4"/>
                 </a:solidFill>
                 <a:latin typeface="Helvetica Neue"/>
               </a:rPr>
@@ -4259,7 +4259,7 @@
             <a:r>
               <a:rPr sz="1500" b="0">
                 <a:solidFill>
-                  <a:srgbClr val="94A3B8"/>
+                  <a:srgbClr val="8FB2B6"/>
                 </a:solidFill>
                 <a:latin typeface="Helvetica Neue"/>
               </a:rPr>
@@ -4294,7 +4294,7 @@
             <a:r>
               <a:rPr sz="1800" b="1">
                 <a:solidFill>
-                  <a:srgbClr val="E2E8F0"/>
+                  <a:srgbClr val="D6EEF0"/>
                 </a:solidFill>
                 <a:latin typeface="Helvetica Neue"/>
               </a:rPr>
@@ -4329,7 +4329,7 @@
             <a:r>
               <a:rPr sz="1300" b="1">
                 <a:solidFill>
-                  <a:srgbClr val="94A3B8"/>
+                  <a:srgbClr val="8FB2B6"/>
                 </a:solidFill>
                 <a:latin typeface="Helvetica Neue"/>
               </a:rPr>
@@ -4364,7 +4364,7 @@
             <a:r>
               <a:rPr sz="1300" b="0">
                 <a:solidFill>
-                  <a:srgbClr val="94A3B8"/>
+                  <a:srgbClr val="8FB2B6"/>
                 </a:solidFill>
                 <a:latin typeface="Helvetica Neue"/>
               </a:rPr>
@@ -4387,7 +4387,7 @@
     <p:bg>
       <p:bgPr>
         <a:solidFill>
-          <a:srgbClr val="0F172A"/>
+          <a:srgbClr val="07171A"/>
         </a:solidFill>
         <a:effectLst/>
       </p:bgPr>
@@ -4414,7 +4414,7 @@
             <a:avLst/>
           </a:prstGeom>
           <a:solidFill>
-            <a:srgbClr val="34D399"/>
+            <a:srgbClr val="2DD4BF"/>
           </a:solidFill>
           <a:ln>
             <a:noFill/>
@@ -4469,7 +4469,7 @@
             <a:r>
               <a:rPr sz="1500" b="1">
                 <a:solidFill>
-                  <a:srgbClr val="34D399"/>
+                  <a:srgbClr val="2DD4BF"/>
                 </a:solidFill>
                 <a:latin typeface="Helvetica Neue"/>
               </a:rPr>
@@ -4504,7 +4504,7 @@
             <a:r>
               <a:rPr sz="3400" b="1">
                 <a:solidFill>
-                  <a:srgbClr val="E2E8F0"/>
+                  <a:srgbClr val="D6EEF0"/>
                 </a:solidFill>
                 <a:latin typeface="Helvetica Neue"/>
               </a:rPr>
@@ -4528,7 +4528,7 @@
             <a:avLst/>
           </a:prstGeom>
           <a:solidFill>
-            <a:srgbClr val="1E293B"/>
+            <a:srgbClr val="0F242A"/>
           </a:solidFill>
           <a:ln>
             <a:noFill/>
@@ -4583,7 +4583,7 @@
             <a:r>
               <a:rPr sz="1900" b="1">
                 <a:solidFill>
-                  <a:srgbClr val="34D399"/>
+                  <a:srgbClr val="2DD4BF"/>
                 </a:solidFill>
                 <a:latin typeface="Helvetica Neue"/>
               </a:rPr>
@@ -4618,7 +4618,7 @@
             <a:r>
               <a:rPr sz="1500" b="0">
                 <a:solidFill>
-                  <a:srgbClr val="E2E8F0"/>
+                  <a:srgbClr val="D6EEF0"/>
                 </a:solidFill>
                 <a:latin typeface="Helvetica Neue"/>
               </a:rPr>
@@ -4630,7 +4630,7 @@
             <a:r>
               <a:rPr sz="1500" b="0">
                 <a:solidFill>
-                  <a:srgbClr val="E2E8F0"/>
+                  <a:srgbClr val="D6EEF0"/>
                 </a:solidFill>
                 <a:latin typeface="Helvetica Neue"/>
               </a:rPr>
@@ -4642,7 +4642,7 @@
             <a:r>
               <a:rPr sz="1500" b="0">
                 <a:solidFill>
-                  <a:srgbClr val="E2E8F0"/>
+                  <a:srgbClr val="D6EEF0"/>
                 </a:solidFill>
                 <a:latin typeface="Helvetica Neue"/>
               </a:rPr>
@@ -4654,7 +4654,7 @@
             <a:r>
               <a:rPr sz="1500" b="0">
                 <a:solidFill>
-                  <a:srgbClr val="E2E8F0"/>
+                  <a:srgbClr val="D6EEF0"/>
                 </a:solidFill>
                 <a:latin typeface="Helvetica Neue"/>
               </a:rPr>
@@ -4678,7 +4678,7 @@
             <a:avLst/>
           </a:prstGeom>
           <a:solidFill>
-            <a:srgbClr val="1E293B"/>
+            <a:srgbClr val="0F242A"/>
           </a:solidFill>
           <a:ln>
             <a:noFill/>
@@ -4733,7 +4733,7 @@
             <a:r>
               <a:rPr sz="1900" b="1">
                 <a:solidFill>
-                  <a:srgbClr val="A78BFA"/>
+                  <a:srgbClr val="5EEAD4"/>
                 </a:solidFill>
                 <a:latin typeface="Helvetica Neue"/>
               </a:rPr>
@@ -4768,7 +4768,7 @@
             <a:r>
               <a:rPr sz="1500" b="0">
                 <a:solidFill>
-                  <a:srgbClr val="E2E8F0"/>
+                  <a:srgbClr val="D6EEF0"/>
                 </a:solidFill>
                 <a:latin typeface="Helvetica Neue"/>
               </a:rPr>
@@ -4780,7 +4780,7 @@
             <a:r>
               <a:rPr sz="1500" b="0">
                 <a:solidFill>
-                  <a:srgbClr val="E2E8F0"/>
+                  <a:srgbClr val="D6EEF0"/>
                 </a:solidFill>
                 <a:latin typeface="Helvetica Neue"/>
               </a:rPr>
@@ -4792,7 +4792,7 @@
             <a:r>
               <a:rPr sz="1500" b="0">
                 <a:solidFill>
-                  <a:srgbClr val="E2E8F0"/>
+                  <a:srgbClr val="D6EEF0"/>
                 </a:solidFill>
                 <a:latin typeface="Helvetica Neue"/>
               </a:rPr>
@@ -4804,7 +4804,7 @@
             <a:r>
               <a:rPr sz="1500" b="0">
                 <a:solidFill>
-                  <a:srgbClr val="E2E8F0"/>
+                  <a:srgbClr val="D6EEF0"/>
                 </a:solidFill>
                 <a:latin typeface="Helvetica Neue"/>
               </a:rPr>
@@ -4839,7 +4839,7 @@
             <a:r>
               <a:rPr sz="1800" b="1">
                 <a:solidFill>
-                  <a:srgbClr val="E2E8F0"/>
+                  <a:srgbClr val="D6EEF0"/>
                 </a:solidFill>
                 <a:latin typeface="Helvetica Neue"/>
               </a:rPr>
@@ -4874,7 +4874,7 @@
             <a:r>
               <a:rPr sz="1300" b="1">
                 <a:solidFill>
-                  <a:srgbClr val="94A3B8"/>
+                  <a:srgbClr val="8FB2B6"/>
                 </a:solidFill>
                 <a:latin typeface="Helvetica Neue"/>
               </a:rPr>
@@ -4909,7 +4909,7 @@
             <a:r>
               <a:rPr sz="1300" b="0">
                 <a:solidFill>
-                  <a:srgbClr val="94A3B8"/>
+                  <a:srgbClr val="8FB2B6"/>
                 </a:solidFill>
                 <a:latin typeface="Helvetica Neue"/>
               </a:rPr>
@@ -4932,7 +4932,7 @@
     <p:bg>
       <p:bgPr>
         <a:solidFill>
-          <a:srgbClr val="0F172A"/>
+          <a:srgbClr val="07171A"/>
         </a:solidFill>
         <a:effectLst/>
       </p:bgPr>
@@ -4959,7 +4959,7 @@
             <a:avLst/>
           </a:prstGeom>
           <a:solidFill>
-            <a:srgbClr val="A78BFA"/>
+            <a:srgbClr val="5EEAD4"/>
           </a:solidFill>
           <a:ln>
             <a:noFill/>
@@ -5014,7 +5014,7 @@
             <a:r>
               <a:rPr sz="1500" b="1">
                 <a:solidFill>
-                  <a:srgbClr val="A78BFA"/>
+                  <a:srgbClr val="5EEAD4"/>
                 </a:solidFill>
                 <a:latin typeface="Helvetica Neue"/>
               </a:rPr>
@@ -5049,7 +5049,7 @@
             <a:r>
               <a:rPr sz="3400" b="1">
                 <a:solidFill>
-                  <a:srgbClr val="E2E8F0"/>
+                  <a:srgbClr val="D6EEF0"/>
                 </a:solidFill>
                 <a:latin typeface="Helvetica Neue"/>
               </a:rPr>
@@ -5073,7 +5073,7 @@
             <a:avLst/>
           </a:prstGeom>
           <a:solidFill>
-            <a:srgbClr val="1E293B"/>
+            <a:srgbClr val="0F242A"/>
           </a:solidFill>
           <a:ln>
             <a:noFill/>
@@ -5117,7 +5117,7 @@
             <a:avLst/>
           </a:prstGeom>
           <a:solidFill>
-            <a:srgbClr val="38BDF8"/>
+            <a:srgbClr val="22D3EE"/>
           </a:solidFill>
           <a:ln>
             <a:noFill/>
@@ -5172,7 +5172,7 @@
             <a:r>
               <a:rPr sz="2100" b="1">
                 <a:solidFill>
-                  <a:srgbClr val="38BDF8"/>
+                  <a:srgbClr val="22D3EE"/>
                 </a:solidFill>
                 <a:latin typeface="Helvetica Neue"/>
               </a:rPr>
@@ -5207,7 +5207,7 @@
             <a:r>
               <a:rPr sz="1400" b="0">
                 <a:solidFill>
-                  <a:srgbClr val="94A3B8"/>
+                  <a:srgbClr val="8FB2B6"/>
                 </a:solidFill>
                 <a:latin typeface="Helvetica Neue"/>
               </a:rPr>
@@ -5242,7 +5242,7 @@
             <a:r>
               <a:rPr sz="1500" b="0">
                 <a:solidFill>
-                  <a:srgbClr val="E2E8F0"/>
+                  <a:srgbClr val="D6EEF0"/>
                 </a:solidFill>
                 <a:latin typeface="Consolas"/>
               </a:rPr>
@@ -5266,7 +5266,7 @@
             <a:avLst/>
           </a:prstGeom>
           <a:solidFill>
-            <a:srgbClr val="1E293B"/>
+            <a:srgbClr val="0F242A"/>
           </a:solidFill>
           <a:ln>
             <a:noFill/>
@@ -5310,7 +5310,7 @@
             <a:avLst/>
           </a:prstGeom>
           <a:solidFill>
-            <a:srgbClr val="34D399"/>
+            <a:srgbClr val="2DD4BF"/>
           </a:solidFill>
           <a:ln>
             <a:noFill/>
@@ -5365,7 +5365,7 @@
             <a:r>
               <a:rPr sz="2100" b="1">
                 <a:solidFill>
-                  <a:srgbClr val="34D399"/>
+                  <a:srgbClr val="2DD4BF"/>
                 </a:solidFill>
                 <a:latin typeface="Helvetica Neue"/>
               </a:rPr>
@@ -5400,7 +5400,7 @@
             <a:r>
               <a:rPr sz="1400" b="0">
                 <a:solidFill>
-                  <a:srgbClr val="94A3B8"/>
+                  <a:srgbClr val="8FB2B6"/>
                 </a:solidFill>
                 <a:latin typeface="Helvetica Neue"/>
               </a:rPr>
@@ -5435,7 +5435,7 @@
             <a:r>
               <a:rPr sz="1500" b="0">
                 <a:solidFill>
-                  <a:srgbClr val="E2E8F0"/>
+                  <a:srgbClr val="D6EEF0"/>
                 </a:solidFill>
                 <a:latin typeface="Consolas"/>
               </a:rPr>
@@ -5459,7 +5459,7 @@
             <a:avLst/>
           </a:prstGeom>
           <a:solidFill>
-            <a:srgbClr val="1E293B"/>
+            <a:srgbClr val="0F242A"/>
           </a:solidFill>
           <a:ln>
             <a:noFill/>
@@ -5503,7 +5503,7 @@
             <a:avLst/>
           </a:prstGeom>
           <a:solidFill>
-            <a:srgbClr val="A78BFA"/>
+            <a:srgbClr val="5EEAD4"/>
           </a:solidFill>
           <a:ln>
             <a:noFill/>
@@ -5558,7 +5558,7 @@
             <a:r>
               <a:rPr sz="2100" b="1">
                 <a:solidFill>
-                  <a:srgbClr val="A78BFA"/>
+                  <a:srgbClr val="5EEAD4"/>
                 </a:solidFill>
                 <a:latin typeface="Helvetica Neue"/>
               </a:rPr>
@@ -5593,7 +5593,7 @@
             <a:r>
               <a:rPr sz="1400" b="0">
                 <a:solidFill>
-                  <a:srgbClr val="94A3B8"/>
+                  <a:srgbClr val="8FB2B6"/>
                 </a:solidFill>
                 <a:latin typeface="Helvetica Neue"/>
               </a:rPr>
@@ -5628,7 +5628,7 @@
             <a:r>
               <a:rPr sz="1500" b="0">
                 <a:solidFill>
-                  <a:srgbClr val="E2E8F0"/>
+                  <a:srgbClr val="D6EEF0"/>
                 </a:solidFill>
                 <a:latin typeface="Consolas"/>
               </a:rPr>
@@ -5663,7 +5663,7 @@
             <a:r>
               <a:rPr sz="1300" b="1">
                 <a:solidFill>
-                  <a:srgbClr val="94A3B8"/>
+                  <a:srgbClr val="8FB2B6"/>
                 </a:solidFill>
                 <a:latin typeface="Helvetica Neue"/>
               </a:rPr>
@@ -5698,7 +5698,7 @@
             <a:r>
               <a:rPr sz="1300" b="0">
                 <a:solidFill>
-                  <a:srgbClr val="94A3B8"/>
+                  <a:srgbClr val="8FB2B6"/>
                 </a:solidFill>
                 <a:latin typeface="Helvetica Neue"/>
               </a:rPr>
@@ -5721,7 +5721,7 @@
     <p:bg>
       <p:bgPr>
         <a:solidFill>
-          <a:srgbClr val="0F172A"/>
+          <a:srgbClr val="07171A"/>
         </a:solidFill>
         <a:effectLst/>
       </p:bgPr>
@@ -5748,7 +5748,7 @@
             <a:avLst/>
           </a:prstGeom>
           <a:solidFill>
-            <a:srgbClr val="FBBF24"/>
+            <a:srgbClr val="67E8F9"/>
           </a:solidFill>
           <a:ln>
             <a:noFill/>
@@ -5803,7 +5803,7 @@
             <a:r>
               <a:rPr sz="1500" b="1">
                 <a:solidFill>
-                  <a:srgbClr val="FBBF24"/>
+                  <a:srgbClr val="67E8F9"/>
                 </a:solidFill>
                 <a:latin typeface="Helvetica Neue"/>
               </a:rPr>
@@ -5838,7 +5838,7 @@
             <a:r>
               <a:rPr sz="3400" b="1">
                 <a:solidFill>
-                  <a:srgbClr val="E2E8F0"/>
+                  <a:srgbClr val="D6EEF0"/>
                 </a:solidFill>
                 <a:latin typeface="Helvetica Neue"/>
               </a:rPr>
@@ -5873,7 +5873,7 @@
             <a:r>
               <a:rPr sz="1500" b="0">
                 <a:solidFill>
-                  <a:srgbClr val="94A3B8"/>
+                  <a:srgbClr val="8FB2B6"/>
                 </a:solidFill>
                 <a:latin typeface="Helvetica Neue"/>
               </a:rPr>
@@ -5897,7 +5897,7 @@
             <a:avLst/>
           </a:prstGeom>
           <a:solidFill>
-            <a:srgbClr val="1E293B"/>
+            <a:srgbClr val="0F242A"/>
           </a:solidFill>
           <a:ln>
             <a:noFill/>
@@ -5952,7 +5952,7 @@
             <a:r>
               <a:rPr sz="5400" b="1">
                 <a:solidFill>
-                  <a:srgbClr val="38BDF8"/>
+                  <a:srgbClr val="22D3EE"/>
                 </a:solidFill>
                 <a:latin typeface="Helvetica Neue"/>
               </a:rPr>
@@ -5987,7 +5987,7 @@
             <a:r>
               <a:rPr sz="1800" b="1">
                 <a:solidFill>
-                  <a:srgbClr val="E2E8F0"/>
+                  <a:srgbClr val="D6EEF0"/>
                 </a:solidFill>
                 <a:latin typeface="Helvetica Neue"/>
               </a:rPr>
@@ -6022,7 +6022,7 @@
             <a:r>
               <a:rPr sz="1300" b="0">
                 <a:solidFill>
-                  <a:srgbClr val="94A3B8"/>
+                  <a:srgbClr val="8FB2B6"/>
                 </a:solidFill>
                 <a:latin typeface="Helvetica Neue"/>
               </a:rPr>
@@ -6046,7 +6046,7 @@
             <a:avLst/>
           </a:prstGeom>
           <a:solidFill>
-            <a:srgbClr val="1E293B"/>
+            <a:srgbClr val="0F242A"/>
           </a:solidFill>
           <a:ln>
             <a:noFill/>
@@ -6101,7 +6101,7 @@
             <a:r>
               <a:rPr sz="5400" b="1">
                 <a:solidFill>
-                  <a:srgbClr val="34D399"/>
+                  <a:srgbClr val="2DD4BF"/>
                 </a:solidFill>
                 <a:latin typeface="Helvetica Neue"/>
               </a:rPr>
@@ -6136,7 +6136,7 @@
             <a:r>
               <a:rPr sz="1800" b="1">
                 <a:solidFill>
-                  <a:srgbClr val="E2E8F0"/>
+                  <a:srgbClr val="D6EEF0"/>
                 </a:solidFill>
                 <a:latin typeface="Helvetica Neue"/>
               </a:rPr>
@@ -6171,7 +6171,7 @@
             <a:r>
               <a:rPr sz="1300" b="0">
                 <a:solidFill>
-                  <a:srgbClr val="94A3B8"/>
+                  <a:srgbClr val="8FB2B6"/>
                 </a:solidFill>
                 <a:latin typeface="Helvetica Neue"/>
               </a:rPr>
@@ -6195,7 +6195,7 @@
             <a:avLst/>
           </a:prstGeom>
           <a:solidFill>
-            <a:srgbClr val="1E293B"/>
+            <a:srgbClr val="0F242A"/>
           </a:solidFill>
           <a:ln>
             <a:noFill/>
@@ -6250,7 +6250,7 @@
             <a:r>
               <a:rPr sz="5400" b="1">
                 <a:solidFill>
-                  <a:srgbClr val="A78BFA"/>
+                  <a:srgbClr val="5EEAD4"/>
                 </a:solidFill>
                 <a:latin typeface="Helvetica Neue"/>
               </a:rPr>
@@ -6285,7 +6285,7 @@
             <a:r>
               <a:rPr sz="1800" b="1">
                 <a:solidFill>
-                  <a:srgbClr val="E2E8F0"/>
+                  <a:srgbClr val="D6EEF0"/>
                 </a:solidFill>
                 <a:latin typeface="Helvetica Neue"/>
               </a:rPr>
@@ -6320,7 +6320,7 @@
             <a:r>
               <a:rPr sz="1300" b="0">
                 <a:solidFill>
-                  <a:srgbClr val="94A3B8"/>
+                  <a:srgbClr val="8FB2B6"/>
                 </a:solidFill>
                 <a:latin typeface="Helvetica Neue"/>
               </a:rPr>
@@ -6344,7 +6344,7 @@
             <a:avLst/>
           </a:prstGeom>
           <a:solidFill>
-            <a:srgbClr val="1E293B"/>
+            <a:srgbClr val="0F242A"/>
           </a:solidFill>
           <a:ln>
             <a:noFill/>
@@ -6399,7 +6399,7 @@
             <a:r>
               <a:rPr sz="5400" b="1">
                 <a:solidFill>
-                  <a:srgbClr val="FBBF24"/>
+                  <a:srgbClr val="67E8F9"/>
                 </a:solidFill>
                 <a:latin typeface="Helvetica Neue"/>
               </a:rPr>
@@ -6434,7 +6434,7 @@
             <a:r>
               <a:rPr sz="1800" b="1">
                 <a:solidFill>
-                  <a:srgbClr val="E2E8F0"/>
+                  <a:srgbClr val="D6EEF0"/>
                 </a:solidFill>
                 <a:latin typeface="Helvetica Neue"/>
               </a:rPr>
@@ -6469,7 +6469,7 @@
             <a:r>
               <a:rPr sz="1300" b="0">
                 <a:solidFill>
-                  <a:srgbClr val="94A3B8"/>
+                  <a:srgbClr val="8FB2B6"/>
                 </a:solidFill>
                 <a:latin typeface="Helvetica Neue"/>
               </a:rPr>
@@ -6493,7 +6493,7 @@
             <a:avLst/>
           </a:prstGeom>
           <a:solidFill>
-            <a:srgbClr val="1E293B"/>
+            <a:srgbClr val="0F242A"/>
           </a:solidFill>
           <a:ln>
             <a:noFill/>
@@ -6548,7 +6548,7 @@
             <a:r>
               <a:rPr sz="5400" b="1">
                 <a:solidFill>
-                  <a:srgbClr val="38BDF8"/>
+                  <a:srgbClr val="22D3EE"/>
                 </a:solidFill>
                 <a:latin typeface="Helvetica Neue"/>
               </a:rPr>
@@ -6583,7 +6583,7 @@
             <a:r>
               <a:rPr sz="1800" b="1">
                 <a:solidFill>
-                  <a:srgbClr val="E2E8F0"/>
+                  <a:srgbClr val="D6EEF0"/>
                 </a:solidFill>
                 <a:latin typeface="Helvetica Neue"/>
               </a:rPr>
@@ -6618,7 +6618,7 @@
             <a:r>
               <a:rPr sz="1300" b="0">
                 <a:solidFill>
-                  <a:srgbClr val="94A3B8"/>
+                  <a:srgbClr val="8FB2B6"/>
                 </a:solidFill>
                 <a:latin typeface="Helvetica Neue"/>
               </a:rPr>
@@ -6653,7 +6653,7 @@
             <a:r>
               <a:rPr sz="1700" b="1">
                 <a:solidFill>
-                  <a:srgbClr val="34D399"/>
+                  <a:srgbClr val="2DD4BF"/>
                 </a:solidFill>
                 <a:latin typeface="Consolas"/>
               </a:rPr>
@@ -6688,7 +6688,7 @@
             <a:r>
               <a:rPr sz="1500" b="0">
                 <a:solidFill>
-                  <a:srgbClr val="94A3B8"/>
+                  <a:srgbClr val="8FB2B6"/>
                 </a:solidFill>
                 <a:latin typeface="Helvetica Neue"/>
               </a:rPr>
@@ -6723,7 +6723,7 @@
             <a:r>
               <a:rPr sz="1300" b="1">
                 <a:solidFill>
-                  <a:srgbClr val="94A3B8"/>
+                  <a:srgbClr val="8FB2B6"/>
                 </a:solidFill>
                 <a:latin typeface="Helvetica Neue"/>
               </a:rPr>
@@ -6758,7 +6758,7 @@
             <a:r>
               <a:rPr sz="1300" b="0">
                 <a:solidFill>
-                  <a:srgbClr val="94A3B8"/>
+                  <a:srgbClr val="8FB2B6"/>
                 </a:solidFill>
                 <a:latin typeface="Helvetica Neue"/>
               </a:rPr>
@@ -6781,7 +6781,7 @@
     <p:bg>
       <p:bgPr>
         <a:solidFill>
-          <a:srgbClr val="0F172A"/>
+          <a:srgbClr val="07171A"/>
         </a:solidFill>
         <a:effectLst/>
       </p:bgPr>
@@ -6808,7 +6808,7 @@
             <a:avLst/>
           </a:prstGeom>
           <a:solidFill>
-            <a:srgbClr val="38BDF8"/>
+            <a:srgbClr val="22D3EE"/>
           </a:solidFill>
           <a:ln>
             <a:noFill/>
@@ -6863,7 +6863,7 @@
             <a:r>
               <a:rPr sz="1500" b="1">
                 <a:solidFill>
-                  <a:srgbClr val="38BDF8"/>
+                  <a:srgbClr val="22D3EE"/>
                 </a:solidFill>
                 <a:latin typeface="Helvetica Neue"/>
               </a:rPr>
@@ -6898,7 +6898,7 @@
             <a:r>
               <a:rPr sz="3400" b="1">
                 <a:solidFill>
-                  <a:srgbClr val="E2E8F0"/>
+                  <a:srgbClr val="D6EEF0"/>
                 </a:solidFill>
                 <a:latin typeface="Helvetica Neue"/>
               </a:rPr>
@@ -6922,7 +6922,7 @@
             <a:avLst/>
           </a:prstGeom>
           <a:solidFill>
-            <a:srgbClr val="1E293B"/>
+            <a:srgbClr val="0F242A"/>
           </a:solidFill>
           <a:ln>
             <a:noFill/>
@@ -6977,7 +6977,7 @@
             <a:r>
               <a:rPr sz="1500" b="1">
                 <a:solidFill>
-                  <a:srgbClr val="38BDF8"/>
+                  <a:srgbClr val="22D3EE"/>
                 </a:solidFill>
                 <a:latin typeface="Helvetica Neue"/>
               </a:rPr>
@@ -7012,7 +7012,7 @@
             <a:r>
               <a:rPr sz="1500" b="0">
                 <a:solidFill>
-                  <a:srgbClr val="E2E8F0"/>
+                  <a:srgbClr val="D6EEF0"/>
                 </a:solidFill>
                 <a:latin typeface="Consolas"/>
               </a:rPr>
@@ -7024,7 +7024,7 @@
             <a:r>
               <a:rPr sz="1500" b="0">
                 <a:solidFill>
-                  <a:srgbClr val="E2E8F0"/>
+                  <a:srgbClr val="D6EEF0"/>
                 </a:solidFill>
                 <a:latin typeface="Consolas"/>
               </a:rPr>
@@ -7036,7 +7036,7 @@
             <a:r>
               <a:rPr sz="1500" b="0">
                 <a:solidFill>
-                  <a:srgbClr val="E2E8F0"/>
+                  <a:srgbClr val="D6EEF0"/>
                 </a:solidFill>
                 <a:latin typeface="Consolas"/>
               </a:rPr>
@@ -7060,7 +7060,7 @@
             <a:avLst/>
           </a:prstGeom>
           <a:solidFill>
-            <a:srgbClr val="1E293B"/>
+            <a:srgbClr val="0F242A"/>
           </a:solidFill>
           <a:ln>
             <a:noFill/>
@@ -7115,7 +7115,7 @@
             <a:r>
               <a:rPr sz="1500" b="1">
                 <a:solidFill>
-                  <a:srgbClr val="34D399"/>
+                  <a:srgbClr val="2DD4BF"/>
                 </a:solidFill>
                 <a:latin typeface="Helvetica Neue"/>
               </a:rPr>
@@ -7150,7 +7150,7 @@
             <a:r>
               <a:rPr sz="1500" b="0">
                 <a:solidFill>
-                  <a:srgbClr val="E2E8F0"/>
+                  <a:srgbClr val="D6EEF0"/>
                 </a:solidFill>
                 <a:latin typeface="Consolas"/>
               </a:rPr>
@@ -7162,7 +7162,7 @@
             <a:r>
               <a:rPr sz="1500" b="0">
                 <a:solidFill>
-                  <a:srgbClr val="E2E8F0"/>
+                  <a:srgbClr val="D6EEF0"/>
                 </a:solidFill>
                 <a:latin typeface="Consolas"/>
               </a:rPr>
@@ -7174,7 +7174,7 @@
             <a:r>
               <a:rPr sz="1500" b="0">
                 <a:solidFill>
-                  <a:srgbClr val="E2E8F0"/>
+                  <a:srgbClr val="D6EEF0"/>
                 </a:solidFill>
                 <a:latin typeface="Consolas"/>
               </a:rPr>
@@ -7198,7 +7198,7 @@
             <a:avLst/>
           </a:prstGeom>
           <a:solidFill>
-            <a:srgbClr val="1E293B"/>
+            <a:srgbClr val="0F242A"/>
           </a:solidFill>
           <a:ln>
             <a:noFill/>
@@ -7253,7 +7253,7 @@
             <a:r>
               <a:rPr sz="1500" b="1">
                 <a:solidFill>
-                  <a:srgbClr val="A78BFA"/>
+                  <a:srgbClr val="5EEAD4"/>
                 </a:solidFill>
                 <a:latin typeface="Helvetica Neue"/>
               </a:rPr>
@@ -7288,7 +7288,7 @@
             <a:r>
               <a:rPr sz="1500" b="0">
                 <a:solidFill>
-                  <a:srgbClr val="E2E8F0"/>
+                  <a:srgbClr val="D6EEF0"/>
                 </a:solidFill>
                 <a:latin typeface="Consolas"/>
               </a:rPr>
@@ -7300,7 +7300,7 @@
             <a:r>
               <a:rPr sz="1500" b="0">
                 <a:solidFill>
-                  <a:srgbClr val="E2E8F0"/>
+                  <a:srgbClr val="D6EEF0"/>
                 </a:solidFill>
                 <a:latin typeface="Consolas"/>
               </a:rPr>
@@ -7312,7 +7312,7 @@
             <a:r>
               <a:rPr sz="1500" b="0">
                 <a:solidFill>
-                  <a:srgbClr val="E2E8F0"/>
+                  <a:srgbClr val="D6EEF0"/>
                 </a:solidFill>
                 <a:latin typeface="Consolas"/>
               </a:rPr>
@@ -7336,7 +7336,7 @@
             <a:avLst/>
           </a:prstGeom>
           <a:solidFill>
-            <a:srgbClr val="1E293B"/>
+            <a:srgbClr val="0F242A"/>
           </a:solidFill>
           <a:ln>
             <a:noFill/>
@@ -7391,7 +7391,7 @@
             <a:r>
               <a:rPr sz="1500" b="1">
                 <a:solidFill>
-                  <a:srgbClr val="FBBF24"/>
+                  <a:srgbClr val="67E8F9"/>
                 </a:solidFill>
                 <a:latin typeface="Helvetica Neue"/>
               </a:rPr>
@@ -7426,7 +7426,7 @@
             <a:r>
               <a:rPr sz="1500" b="0">
                 <a:solidFill>
-                  <a:srgbClr val="E2E8F0"/>
+                  <a:srgbClr val="D6EEF0"/>
                 </a:solidFill>
                 <a:latin typeface="Consolas"/>
               </a:rPr>
@@ -7438,7 +7438,7 @@
             <a:r>
               <a:rPr sz="1500" b="0">
                 <a:solidFill>
-                  <a:srgbClr val="E2E8F0"/>
+                  <a:srgbClr val="D6EEF0"/>
                 </a:solidFill>
                 <a:latin typeface="Consolas"/>
               </a:rPr>
@@ -7450,7 +7450,7 @@
             <a:r>
               <a:rPr sz="1500" b="0">
                 <a:solidFill>
-                  <a:srgbClr val="E2E8F0"/>
+                  <a:srgbClr val="D6EEF0"/>
                 </a:solidFill>
                 <a:latin typeface="Consolas"/>
               </a:rPr>
@@ -7485,7 +7485,7 @@
             <a:r>
               <a:rPr sz="1400" b="0">
                 <a:solidFill>
-                  <a:srgbClr val="94A3B8"/>
+                  <a:srgbClr val="8FB2B6"/>
                 </a:solidFill>
                 <a:latin typeface="Helvetica Neue"/>
               </a:rPr>
@@ -7520,7 +7520,7 @@
             <a:r>
               <a:rPr sz="1300" b="1">
                 <a:solidFill>
-                  <a:srgbClr val="94A3B8"/>
+                  <a:srgbClr val="8FB2B6"/>
                 </a:solidFill>
                 <a:latin typeface="Helvetica Neue"/>
               </a:rPr>
@@ -7555,7 +7555,7 @@
             <a:r>
               <a:rPr sz="1300" b="0">
                 <a:solidFill>
-                  <a:srgbClr val="94A3B8"/>
+                  <a:srgbClr val="8FB2B6"/>
                 </a:solidFill>
                 <a:latin typeface="Helvetica Neue"/>
               </a:rPr>
@@ -7578,7 +7578,7 @@
     <p:bg>
       <p:bgPr>
         <a:solidFill>
-          <a:srgbClr val="0F172A"/>
+          <a:srgbClr val="07171A"/>
         </a:solidFill>
         <a:effectLst/>
       </p:bgPr>
@@ -7605,7 +7605,7 @@
             <a:avLst/>
           </a:prstGeom>
           <a:solidFill>
-            <a:srgbClr val="34D399"/>
+            <a:srgbClr val="2DD4BF"/>
           </a:solidFill>
           <a:ln>
             <a:noFill/>
@@ -7660,7 +7660,7 @@
             <a:r>
               <a:rPr sz="1500" b="1">
                 <a:solidFill>
-                  <a:srgbClr val="34D399"/>
+                  <a:srgbClr val="2DD4BF"/>
                 </a:solidFill>
                 <a:latin typeface="Helvetica Neue"/>
               </a:rPr>
@@ -7695,7 +7695,7 @@
             <a:r>
               <a:rPr sz="3400" b="1">
                 <a:solidFill>
-                  <a:srgbClr val="E2E8F0"/>
+                  <a:srgbClr val="D6EEF0"/>
                 </a:solidFill>
                 <a:latin typeface="Helvetica Neue"/>
               </a:rPr>
@@ -7719,7 +7719,7 @@
             <a:avLst/>
           </a:prstGeom>
           <a:solidFill>
-            <a:srgbClr val="1E293B"/>
+            <a:srgbClr val="0F242A"/>
           </a:solidFill>
           <a:ln>
             <a:noFill/>
@@ -7763,7 +7763,7 @@
             <a:avLst/>
           </a:prstGeom>
           <a:solidFill>
-            <a:srgbClr val="38BDF8"/>
+            <a:srgbClr val="22D3EE"/>
           </a:solidFill>
           <a:ln>
             <a:noFill/>
@@ -7818,7 +7818,7 @@
             <a:r>
               <a:rPr sz="1900" b="1">
                 <a:solidFill>
-                  <a:srgbClr val="38BDF8"/>
+                  <a:srgbClr val="22D3EE"/>
                 </a:solidFill>
                 <a:latin typeface="Helvetica Neue"/>
               </a:rPr>
@@ -7853,7 +7853,7 @@
             <a:r>
               <a:rPr sz="1400" b="0">
                 <a:solidFill>
-                  <a:srgbClr val="94A3B8"/>
+                  <a:srgbClr val="8FB2B6"/>
                 </a:solidFill>
                 <a:latin typeface="Helvetica Neue"/>
               </a:rPr>
@@ -7888,7 +7888,7 @@
             <a:r>
               <a:rPr sz="1500" b="0">
                 <a:solidFill>
-                  <a:srgbClr val="E2E8F0"/>
+                  <a:srgbClr val="D6EEF0"/>
                 </a:solidFill>
                 <a:latin typeface="Consolas"/>
               </a:rPr>
@@ -7912,7 +7912,7 @@
             <a:avLst/>
           </a:prstGeom>
           <a:solidFill>
-            <a:srgbClr val="1E293B"/>
+            <a:srgbClr val="0F242A"/>
           </a:solidFill>
           <a:ln>
             <a:noFill/>
@@ -7956,7 +7956,7 @@
             <a:avLst/>
           </a:prstGeom>
           <a:solidFill>
-            <a:srgbClr val="A78BFA"/>
+            <a:srgbClr val="5EEAD4"/>
           </a:solidFill>
           <a:ln>
             <a:noFill/>
@@ -8011,7 +8011,7 @@
             <a:r>
               <a:rPr sz="1900" b="1">
                 <a:solidFill>
-                  <a:srgbClr val="A78BFA"/>
+                  <a:srgbClr val="5EEAD4"/>
                 </a:solidFill>
                 <a:latin typeface="Helvetica Neue"/>
               </a:rPr>
@@ -8046,7 +8046,7 @@
             <a:r>
               <a:rPr sz="1400" b="0">
                 <a:solidFill>
-                  <a:srgbClr val="94A3B8"/>
+                  <a:srgbClr val="8FB2B6"/>
                 </a:solidFill>
                 <a:latin typeface="Helvetica Neue"/>
               </a:rPr>
@@ -8081,7 +8081,7 @@
             <a:r>
               <a:rPr sz="1500" b="0">
                 <a:solidFill>
-                  <a:srgbClr val="E2E8F0"/>
+                  <a:srgbClr val="D6EEF0"/>
                 </a:solidFill>
                 <a:latin typeface="Consolas"/>
               </a:rPr>
@@ -8105,7 +8105,7 @@
             <a:avLst/>
           </a:prstGeom>
           <a:solidFill>
-            <a:srgbClr val="1E293B"/>
+            <a:srgbClr val="0F242A"/>
           </a:solidFill>
           <a:ln>
             <a:noFill/>
@@ -8149,7 +8149,7 @@
             <a:avLst/>
           </a:prstGeom>
           <a:solidFill>
-            <a:srgbClr val="FBBF24"/>
+            <a:srgbClr val="67E8F9"/>
           </a:solidFill>
           <a:ln>
             <a:noFill/>
@@ -8204,7 +8204,7 @@
             <a:r>
               <a:rPr sz="1900" b="1">
                 <a:solidFill>
-                  <a:srgbClr val="FBBF24"/>
+                  <a:srgbClr val="67E8F9"/>
                 </a:solidFill>
                 <a:latin typeface="Helvetica Neue"/>
               </a:rPr>
@@ -8239,7 +8239,7 @@
             <a:r>
               <a:rPr sz="1400" b="0">
                 <a:solidFill>
-                  <a:srgbClr val="94A3B8"/>
+                  <a:srgbClr val="8FB2B6"/>
                 </a:solidFill>
                 <a:latin typeface="Helvetica Neue"/>
               </a:rPr>
@@ -8274,7 +8274,7 @@
             <a:r>
               <a:rPr sz="1500" b="0">
                 <a:solidFill>
-                  <a:srgbClr val="E2E8F0"/>
+                  <a:srgbClr val="D6EEF0"/>
                 </a:solidFill>
                 <a:latin typeface="Consolas"/>
               </a:rPr>
@@ -8309,7 +8309,7 @@
             <a:r>
               <a:rPr sz="1300" b="1">
                 <a:solidFill>
-                  <a:srgbClr val="94A3B8"/>
+                  <a:srgbClr val="8FB2B6"/>
                 </a:solidFill>
                 <a:latin typeface="Helvetica Neue"/>
               </a:rPr>
@@ -8344,7 +8344,7 @@
             <a:r>
               <a:rPr sz="1300" b="0">
                 <a:solidFill>
-                  <a:srgbClr val="94A3B8"/>
+                  <a:srgbClr val="8FB2B6"/>
                 </a:solidFill>
                 <a:latin typeface="Helvetica Neue"/>
               </a:rPr>
@@ -8367,7 +8367,7 @@
     <p:bg>
       <p:bgPr>
         <a:solidFill>
-          <a:srgbClr val="0F172A"/>
+          <a:srgbClr val="07171A"/>
         </a:solidFill>
         <a:effectLst/>
       </p:bgPr>
@@ -8394,7 +8394,7 @@
             <a:avLst/>
           </a:prstGeom>
           <a:solidFill>
-            <a:srgbClr val="34D399"/>
+            <a:srgbClr val="2DD4BF"/>
           </a:solidFill>
           <a:ln>
             <a:noFill/>
@@ -8449,7 +8449,7 @@
             <a:r>
               <a:rPr sz="1500" b="1">
                 <a:solidFill>
-                  <a:srgbClr val="34D399"/>
+                  <a:srgbClr val="2DD4BF"/>
                 </a:solidFill>
                 <a:latin typeface="Helvetica Neue"/>
               </a:rPr>
@@ -8484,7 +8484,7 @@
             <a:r>
               <a:rPr sz="3400" b="1">
                 <a:solidFill>
-                  <a:srgbClr val="E2E8F0"/>
+                  <a:srgbClr val="D6EEF0"/>
                 </a:solidFill>
                 <a:latin typeface="Helvetica Neue"/>
               </a:rPr>
@@ -8519,7 +8519,7 @@
             <a:r>
               <a:rPr sz="1500" b="0">
                 <a:solidFill>
-                  <a:srgbClr val="94A3B8"/>
+                  <a:srgbClr val="8FB2B6"/>
                 </a:solidFill>
                 <a:latin typeface="Consolas"/>
               </a:rPr>
@@ -8543,7 +8543,7 @@
             <a:avLst/>
           </a:prstGeom>
           <a:solidFill>
-            <a:srgbClr val="1E293B"/>
+            <a:srgbClr val="0F242A"/>
           </a:solidFill>
           <a:ln>
             <a:noFill/>
@@ -8587,7 +8587,7 @@
             <a:avLst/>
           </a:prstGeom>
           <a:solidFill>
-            <a:srgbClr val="38BDF8"/>
+            <a:srgbClr val="22D3EE"/>
           </a:solidFill>
           <a:ln>
             <a:noFill/>
@@ -8642,7 +8642,7 @@
             <a:r>
               <a:rPr sz="1800" b="1">
                 <a:solidFill>
-                  <a:srgbClr val="38BDF8"/>
+                  <a:srgbClr val="22D3EE"/>
                 </a:solidFill>
                 <a:latin typeface="Helvetica Neue"/>
               </a:rPr>
@@ -8677,7 +8677,7 @@
             <a:r>
               <a:rPr sz="1400" b="0">
                 <a:solidFill>
-                  <a:srgbClr val="E2E8F0"/>
+                  <a:srgbClr val="D6EEF0"/>
                 </a:solidFill>
                 <a:latin typeface="Consolas"/>
               </a:rPr>
@@ -8712,7 +8712,7 @@
             <a:r>
               <a:rPr sz="1400" b="0">
                 <a:solidFill>
-                  <a:srgbClr val="94A3B8"/>
+                  <a:srgbClr val="8FB2B6"/>
                 </a:solidFill>
                 <a:latin typeface="Consolas"/>
               </a:rPr>
@@ -8736,7 +8736,7 @@
             <a:avLst/>
           </a:prstGeom>
           <a:solidFill>
-            <a:srgbClr val="1E293B"/>
+            <a:srgbClr val="0F242A"/>
           </a:solidFill>
           <a:ln>
             <a:noFill/>
@@ -8780,7 +8780,7 @@
             <a:avLst/>
           </a:prstGeom>
           <a:solidFill>
-            <a:srgbClr val="A78BFA"/>
+            <a:srgbClr val="5EEAD4"/>
           </a:solidFill>
           <a:ln>
             <a:noFill/>
@@ -8835,7 +8835,7 @@
             <a:r>
               <a:rPr sz="1800" b="1">
                 <a:solidFill>
-                  <a:srgbClr val="A78BFA"/>
+                  <a:srgbClr val="5EEAD4"/>
                 </a:solidFill>
                 <a:latin typeface="Helvetica Neue"/>
               </a:rPr>
@@ -8870,7 +8870,7 @@
             <a:r>
               <a:rPr sz="1400" b="0">
                 <a:solidFill>
-                  <a:srgbClr val="E2E8F0"/>
+                  <a:srgbClr val="D6EEF0"/>
                 </a:solidFill>
                 <a:latin typeface="Consolas"/>
               </a:rPr>
@@ -8905,7 +8905,7 @@
             <a:r>
               <a:rPr sz="1400" b="0">
                 <a:solidFill>
-                  <a:srgbClr val="94A3B8"/>
+                  <a:srgbClr val="8FB2B6"/>
                 </a:solidFill>
                 <a:latin typeface="Consolas"/>
               </a:rPr>
@@ -8929,7 +8929,7 @@
             <a:avLst/>
           </a:prstGeom>
           <a:solidFill>
-            <a:srgbClr val="1E293B"/>
+            <a:srgbClr val="0F242A"/>
           </a:solidFill>
           <a:ln>
             <a:noFill/>
@@ -8973,7 +8973,7 @@
             <a:avLst/>
           </a:prstGeom>
           <a:solidFill>
-            <a:srgbClr val="FBBF24"/>
+            <a:srgbClr val="67E8F9"/>
           </a:solidFill>
           <a:ln>
             <a:noFill/>
@@ -9028,7 +9028,7 @@
             <a:r>
               <a:rPr sz="1800" b="1">
                 <a:solidFill>
-                  <a:srgbClr val="FBBF24"/>
+                  <a:srgbClr val="67E8F9"/>
                 </a:solidFill>
                 <a:latin typeface="Helvetica Neue"/>
               </a:rPr>
@@ -9063,7 +9063,7 @@
             <a:r>
               <a:rPr sz="1400" b="0">
                 <a:solidFill>
-                  <a:srgbClr val="E2E8F0"/>
+                  <a:srgbClr val="D6EEF0"/>
                 </a:solidFill>
                 <a:latin typeface="Consolas"/>
               </a:rPr>
@@ -9098,7 +9098,7 @@
             <a:r>
               <a:rPr sz="1400" b="0">
                 <a:solidFill>
-                  <a:srgbClr val="94A3B8"/>
+                  <a:srgbClr val="8FB2B6"/>
                 </a:solidFill>
                 <a:latin typeface="Consolas"/>
               </a:rPr>
@@ -9122,7 +9122,7 @@
             <a:avLst/>
           </a:prstGeom>
           <a:solidFill>
-            <a:srgbClr val="172033"/>
+            <a:srgbClr val="0B2026"/>
           </a:solidFill>
           <a:ln>
             <a:noFill/>
@@ -9177,7 +9177,7 @@
             <a:r>
               <a:rPr sz="1600" b="1">
                 <a:solidFill>
-                  <a:srgbClr val="34D399"/>
+                  <a:srgbClr val="2DD4BF"/>
                 </a:solidFill>
                 <a:latin typeface="Helvetica Neue"/>
               </a:rPr>
@@ -9212,7 +9212,7 @@
             <a:r>
               <a:rPr sz="1500" b="0">
                 <a:solidFill>
-                  <a:srgbClr val="E2E8F0"/>
+                  <a:srgbClr val="D6EEF0"/>
                 </a:solidFill>
                 <a:latin typeface="Consolas"/>
               </a:rPr>
@@ -9247,7 +9247,7 @@
             <a:r>
               <a:rPr sz="1500" b="0">
                 <a:solidFill>
-                  <a:srgbClr val="E2E8F0"/>
+                  <a:srgbClr val="D6EEF0"/>
                 </a:solidFill>
                 <a:latin typeface="Consolas"/>
               </a:rPr>
@@ -9282,7 +9282,7 @@
             <a:r>
               <a:rPr sz="1600" b="1">
                 <a:solidFill>
-                  <a:srgbClr val="E2E8F0"/>
+                  <a:srgbClr val="D6EEF0"/>
                 </a:solidFill>
                 <a:latin typeface="Helvetica Neue"/>
               </a:rPr>
@@ -9317,7 +9317,7 @@
             <a:r>
               <a:rPr sz="1300" b="1">
                 <a:solidFill>
-                  <a:srgbClr val="94A3B8"/>
+                  <a:srgbClr val="8FB2B6"/>
                 </a:solidFill>
                 <a:latin typeface="Helvetica Neue"/>
               </a:rPr>
@@ -9352,7 +9352,7 @@
             <a:r>
               <a:rPr sz="1300" b="0">
                 <a:solidFill>
-                  <a:srgbClr val="94A3B8"/>
+                  <a:srgbClr val="8FB2B6"/>
                 </a:solidFill>
                 <a:latin typeface="Helvetica Neue"/>
               </a:rPr>
@@ -9375,7 +9375,7 @@
     <p:bg>
       <p:bgPr>
         <a:solidFill>
-          <a:srgbClr val="0F172A"/>
+          <a:srgbClr val="07171A"/>
         </a:solidFill>
         <a:effectLst/>
       </p:bgPr>
@@ -9402,7 +9402,7 @@
             <a:avLst/>
           </a:prstGeom>
           <a:solidFill>
-            <a:srgbClr val="A78BFA"/>
+            <a:srgbClr val="5EEAD4"/>
           </a:solidFill>
           <a:ln>
             <a:noFill/>
@@ -9457,7 +9457,7 @@
             <a:r>
               <a:rPr sz="1500" b="1">
                 <a:solidFill>
-                  <a:srgbClr val="A78BFA"/>
+                  <a:srgbClr val="5EEAD4"/>
                 </a:solidFill>
                 <a:latin typeface="Helvetica Neue"/>
               </a:rPr>
@@ -9492,7 +9492,7 @@
             <a:r>
               <a:rPr sz="3400" b="1">
                 <a:solidFill>
-                  <a:srgbClr val="E2E8F0"/>
+                  <a:srgbClr val="D6EEF0"/>
                 </a:solidFill>
                 <a:latin typeface="Helvetica Neue"/>
               </a:rPr>
@@ -9516,7 +9516,7 @@
             <a:avLst/>
           </a:prstGeom>
           <a:solidFill>
-            <a:srgbClr val="172033"/>
+            <a:srgbClr val="0B2026"/>
           </a:solidFill>
           <a:ln>
             <a:noFill/>
@@ -9570,7 +9570,7 @@
             <a:r>
               <a:rPr sz="1500">
                 <a:solidFill>
-                  <a:srgbClr val="94A3B8"/>
+                  <a:srgbClr val="8FB2B6"/>
                 </a:solidFill>
                 <a:latin typeface="Consolas"/>
               </a:rPr>
@@ -9581,7 +9581,7 @@
             <a:r>
               <a:rPr sz="1500">
                 <a:solidFill>
-                  <a:srgbClr val="34D399"/>
+                  <a:srgbClr val="2DD4BF"/>
                 </a:solidFill>
                 <a:latin typeface="Consolas"/>
               </a:rPr>
@@ -9592,7 +9592,7 @@
             <a:r>
               <a:rPr sz="1500">
                 <a:solidFill>
-                  <a:srgbClr val="E2E8F0"/>
+                  <a:srgbClr val="D6EEF0"/>
                 </a:solidFill>
                 <a:latin typeface="Consolas"/>
               </a:rPr>
@@ -9603,7 +9603,7 @@
             <a:r>
               <a:rPr sz="1500">
                 <a:solidFill>
-                  <a:srgbClr val="E2E8F0"/>
+                  <a:srgbClr val="D6EEF0"/>
                 </a:solidFill>
                 <a:latin typeface="Consolas"/>
               </a:rPr>
@@ -9614,7 +9614,7 @@
             <a:r>
               <a:rPr sz="1500">
                 <a:solidFill>
-                  <a:srgbClr val="94A3B8"/>
+                  <a:srgbClr val="8FB2B6"/>
                 </a:solidFill>
                 <a:latin typeface="Consolas"/>
               </a:rPr>
@@ -9625,7 +9625,7 @@
             <a:r>
               <a:rPr sz="1500">
                 <a:solidFill>
-                  <a:srgbClr val="34D399"/>
+                  <a:srgbClr val="2DD4BF"/>
                 </a:solidFill>
                 <a:latin typeface="Consolas"/>
               </a:rPr>
@@ -9636,7 +9636,7 @@
             <a:r>
               <a:rPr sz="1500">
                 <a:solidFill>
-                  <a:srgbClr val="E2E8F0"/>
+                  <a:srgbClr val="D6EEF0"/>
                 </a:solidFill>
                 <a:latin typeface="Consolas"/>
               </a:rPr>
@@ -9647,7 +9647,7 @@
             <a:r>
               <a:rPr sz="1500">
                 <a:solidFill>
-                  <a:srgbClr val="E2E8F0"/>
+                  <a:srgbClr val="D6EEF0"/>
                 </a:solidFill>
                 <a:latin typeface="Consolas"/>
               </a:rPr>
@@ -9658,7 +9658,7 @@
             <a:r>
               <a:rPr sz="1500">
                 <a:solidFill>
-                  <a:srgbClr val="94A3B8"/>
+                  <a:srgbClr val="8FB2B6"/>
                 </a:solidFill>
                 <a:latin typeface="Consolas"/>
               </a:rPr>
@@ -9669,7 +9669,7 @@
             <a:r>
               <a:rPr sz="1500">
                 <a:solidFill>
-                  <a:srgbClr val="34D399"/>
+                  <a:srgbClr val="2DD4BF"/>
                 </a:solidFill>
                 <a:latin typeface="Consolas"/>
               </a:rPr>
@@ -9704,7 +9704,7 @@
             <a:r>
               <a:rPr sz="1500" b="0">
                 <a:solidFill>
-                  <a:srgbClr val="94A3B8"/>
+                  <a:srgbClr val="8FB2B6"/>
                 </a:solidFill>
                 <a:latin typeface="Helvetica Neue"/>
               </a:rPr>
@@ -9739,7 +9739,7 @@
             <a:r>
               <a:rPr sz="1300" b="1">
                 <a:solidFill>
-                  <a:srgbClr val="94A3B8"/>
+                  <a:srgbClr val="8FB2B6"/>
                 </a:solidFill>
                 <a:latin typeface="Helvetica Neue"/>
               </a:rPr>
@@ -9774,7 +9774,7 @@
             <a:r>
               <a:rPr sz="1300" b="0">
                 <a:solidFill>
-                  <a:srgbClr val="94A3B8"/>
+                  <a:srgbClr val="8FB2B6"/>
                 </a:solidFill>
                 <a:latin typeface="Helvetica Neue"/>
               </a:rPr>

</xml_diff>

<commit_message>
Define speccord on its own terms; remove references to other frameworks
- README/USAGE: reframe as Extract / Generate / Enforce (drop superset/lineage framing)
- deck: retitle the overview slide; title chips -> Extract/Generate/Enforce; rename 04 slide
- code comments + package.json: drop framework name-drops
- ROADMAP: restate goals without naming other tools
</commit_message>
<xml_diff>
--- a/docs/speccord-deck.pptx
+++ b/docs/speccord-deck.pptx
@@ -3336,7 +3336,7 @@
                 </a:solidFill>
                 <a:latin typeface="Helvetica Neue"/>
               </a:rPr>
-              <a:t>A spec-driven development CLI — a configurable superset of</a:t>
+              <a:t>A spec-driven development CLI — keep code and spec in sync, both ways</a:t>
             </a:r>
           </a:p>
         </p:txBody>
@@ -3417,7 +3417,7 @@
                 </a:solidFill>
                 <a:latin typeface="Helvetica Neue"/>
               </a:rPr>
-              <a:t>spec-kit · generative</a:t>
+              <a:t>Extract</a:t>
             </a:r>
           </a:p>
         </p:txBody>
@@ -3498,7 +3498,7 @@
                 </a:solidFill>
                 <a:latin typeface="Helvetica Neue"/>
               </a:rPr>
-              <a:t>speccord · enforcement</a:t>
+              <a:t>Generate</a:t>
             </a:r>
           </a:p>
         </p:txBody>
@@ -3579,7 +3579,7 @@
                 </a:solidFill>
                 <a:latin typeface="Helvetica Neue"/>
               </a:rPr>
-              <a:t>BMAD · agentic agile</a:t>
+              <a:t>Enforce</a:t>
             </a:r>
           </a:p>
         </p:txBody>
@@ -5018,7 +5018,7 @@
                 </a:solidFill>
                 <a:latin typeface="Helvetica Neue"/>
               </a:rPr>
-              <a:t>THE SUPERSET</a:t>
+              <a:t>ONE TOOL, BOTH WAYS</a:t>
             </a:r>
           </a:p>
         </p:txBody>
@@ -5053,7 +5053,7 @@
                 </a:solidFill>
                 <a:latin typeface="Helvetica Neue"/>
               </a:rPr>
-              <a:t>Three lineages, one CLI</a:t>
+              <a:t>What speccord does</a:t>
             </a:r>
           </a:p>
         </p:txBody>
@@ -5176,7 +5176,7 @@
                 </a:solidFill>
                 <a:latin typeface="Helvetica Neue"/>
               </a:rPr>
-              <a:t>spec-kit</a:t>
+              <a:t>Extract</a:t>
             </a:r>
           </a:p>
         </p:txBody>
@@ -5211,7 +5211,7 @@
                 </a:solidFill>
                 <a:latin typeface="Helvetica Neue"/>
               </a:rPr>
-              <a:t>Generative chain</a:t>
+              <a:t>code -&gt; spec</a:t>
             </a:r>
           </a:p>
         </p:txBody>
@@ -5246,7 +5246,7 @@
                 </a:solidFill>
                 <a:latin typeface="Consolas"/>
               </a:rPr>
-              <a:t>constitution -&gt; spec -&gt; plan -&gt; tasks -&gt; implement</a:t>
+              <a:t>discover the as-is contract: API · data · events · security</a:t>
             </a:r>
           </a:p>
         </p:txBody>
@@ -5369,7 +5369,7 @@
                 </a:solidFill>
                 <a:latin typeface="Helvetica Neue"/>
               </a:rPr>
-              <a:t>speccord</a:t>
+              <a:t>Generate</a:t>
             </a:r>
           </a:p>
         </p:txBody>
@@ -5404,7 +5404,7 @@
                 </a:solidFill>
                 <a:latin typeface="Helvetica Neue"/>
               </a:rPr>
-              <a:t>Extraction + enforcement</a:t>
+              <a:t>spec -&gt; code</a:t>
             </a:r>
           </a:p>
         </p:txBody>
@@ -5439,7 +5439,7 @@
                 </a:solidFill>
                 <a:latin typeface="Consolas"/>
               </a:rPr>
-              <a:t>discover · lifecycle gates · CI drift gate · conform</a:t>
+              <a:t>constitution -&gt; spec -&gt; plan -&gt; tasks -&gt; story -&gt; implement</a:t>
             </a:r>
           </a:p>
         </p:txBody>
@@ -5562,7 +5562,7 @@
                 </a:solidFill>
                 <a:latin typeface="Helvetica Neue"/>
               </a:rPr>
-              <a:t>BMAD-METHOD</a:t>
+              <a:t>Enforce</a:t>
             </a:r>
           </a:p>
         </p:txBody>
@@ -5597,7 +5597,7 @@
                 </a:solidFill>
                 <a:latin typeface="Helvetica Neue"/>
               </a:rPr>
-              <a:t>Agentic agile</a:t>
+              <a:t>keep them in sync</a:t>
             </a:r>
           </a:p>
         </p:txBody>
@@ -5632,7 +5632,7 @@
                 </a:solidFill>
                 <a:latin typeface="Consolas"/>
               </a:rPr>
-              <a:t>role personas · scale-adaptive · PRD -&gt; epics -&gt; stories</a:t>
+              <a:t>lifecycle gates · CI drift gate · runtime conformance</a:t>
             </a:r>
           </a:p>
         </p:txBody>
@@ -9662,7 +9662,7 @@
                 </a:solidFill>
                 <a:latin typeface="Consolas"/>
               </a:rPr>
-              <a:t># product / BMAD-style</a:t>
+              <a:t># product workflow</a:t>
             </a:r>
           </a:p>
           <a:p>

</xml_diff>

<commit_message>
Coral theme + hexagon-S logo + GitHub Pages docs site
- new logo: coral-gradient hexagon with S monogram (logo.svg/png, banner.svg)
- re-tone all assets teal -> coral (slides, deck, poster, demo, social-preview)
- docs/index.html: documentation site (hero, why, install, examples, commands, agents)
- Pages workflow now deploys all of docs/ (site root = docs page, demo at /demo/)
- README: docs-site + demo links
</commit_message>
<xml_diff>
--- a/docs/speccord-deck.pptx
+++ b/docs/speccord-deck.pptx
@@ -3092,7 +3092,7 @@
     <p:bg>
       <p:bgPr>
         <a:solidFill>
-          <a:srgbClr val="07171A"/>
+          <a:srgbClr val="1D1411"/>
         </a:solidFill>
         <a:effectLst/>
       </p:bgPr>
@@ -3119,7 +3119,7 @@
             <a:avLst/>
           </a:prstGeom>
           <a:solidFill>
-            <a:srgbClr val="22D3EE"/>
+            <a:srgbClr val="FF7A5C"/>
           </a:solidFill>
           <a:ln>
             <a:noFill/>
@@ -3163,7 +3163,7 @@
             <a:avLst/>
           </a:prstGeom>
           <a:solidFill>
-            <a:srgbClr val="2DD4BF"/>
+            <a:srgbClr val="FFA886"/>
           </a:solidFill>
           <a:ln>
             <a:noFill/>
@@ -3207,7 +3207,7 @@
             <a:avLst/>
           </a:prstGeom>
           <a:solidFill>
-            <a:srgbClr val="5EEAD4"/>
+            <a:srgbClr val="E85A63"/>
           </a:solidFill>
           <a:ln>
             <a:noFill/>
@@ -3262,7 +3262,7 @@
             <a:r>
               <a:rPr sz="9600" b="1">
                 <a:solidFill>
-                  <a:srgbClr val="D6EEF0"/>
+                  <a:srgbClr val="F7E9E3"/>
                 </a:solidFill>
                 <a:latin typeface="Helvetica Neue"/>
               </a:rPr>
@@ -3297,7 +3297,7 @@
             <a:r>
               <a:rPr sz="2200" b="0">
                 <a:solidFill>
-                  <a:srgbClr val="22D3EE"/>
+                  <a:srgbClr val="FF7A5C"/>
                 </a:solidFill>
                 <a:latin typeface="Helvetica Neue"/>
               </a:rPr>
@@ -3332,7 +3332,7 @@
             <a:r>
               <a:rPr sz="1800" b="0">
                 <a:solidFill>
-                  <a:srgbClr val="8FB2B6"/>
+                  <a:srgbClr val="BB9A8D"/>
                 </a:solidFill>
                 <a:latin typeface="Helvetica Neue"/>
               </a:rPr>
@@ -3356,11 +3356,11 @@
             <a:avLst/>
           </a:prstGeom>
           <a:solidFill>
-            <a:srgbClr val="07171A"/>
+            <a:srgbClr val="1D1411"/>
           </a:solidFill>
           <a:ln w="25400">
             <a:solidFill>
-              <a:srgbClr val="22D3EE"/>
+              <a:srgbClr val="FF7A5C"/>
             </a:solidFill>
           </a:ln>
           <a:effectLst/>
@@ -3413,7 +3413,7 @@
             <a:r>
               <a:rPr sz="1500" b="1">
                 <a:solidFill>
-                  <a:srgbClr val="22D3EE"/>
+                  <a:srgbClr val="FF7A5C"/>
                 </a:solidFill>
                 <a:latin typeface="Helvetica Neue"/>
               </a:rPr>
@@ -3437,11 +3437,11 @@
             <a:avLst/>
           </a:prstGeom>
           <a:solidFill>
-            <a:srgbClr val="07171A"/>
+            <a:srgbClr val="1D1411"/>
           </a:solidFill>
           <a:ln w="25400">
             <a:solidFill>
-              <a:srgbClr val="2DD4BF"/>
+              <a:srgbClr val="FFA886"/>
             </a:solidFill>
           </a:ln>
           <a:effectLst/>
@@ -3494,7 +3494,7 @@
             <a:r>
               <a:rPr sz="1500" b="1">
                 <a:solidFill>
-                  <a:srgbClr val="2DD4BF"/>
+                  <a:srgbClr val="FFA886"/>
                 </a:solidFill>
                 <a:latin typeface="Helvetica Neue"/>
               </a:rPr>
@@ -3518,11 +3518,11 @@
             <a:avLst/>
           </a:prstGeom>
           <a:solidFill>
-            <a:srgbClr val="07171A"/>
+            <a:srgbClr val="1D1411"/>
           </a:solidFill>
           <a:ln w="25400">
             <a:solidFill>
-              <a:srgbClr val="5EEAD4"/>
+              <a:srgbClr val="E85A63"/>
             </a:solidFill>
           </a:ln>
           <a:effectLst/>
@@ -3575,7 +3575,7 @@
             <a:r>
               <a:rPr sz="1500" b="1">
                 <a:solidFill>
-                  <a:srgbClr val="5EEAD4"/>
+                  <a:srgbClr val="E85A63"/>
                 </a:solidFill>
                 <a:latin typeface="Helvetica Neue"/>
               </a:rPr>
@@ -3610,7 +3610,7 @@
             <a:r>
               <a:rPr sz="1300" b="1">
                 <a:solidFill>
-                  <a:srgbClr val="8FB2B6"/>
+                  <a:srgbClr val="BB9A8D"/>
                 </a:solidFill>
                 <a:latin typeface="Helvetica Neue"/>
               </a:rPr>
@@ -3645,7 +3645,7 @@
             <a:r>
               <a:rPr sz="1300" b="0">
                 <a:solidFill>
-                  <a:srgbClr val="8FB2B6"/>
+                  <a:srgbClr val="BB9A8D"/>
                 </a:solidFill>
                 <a:latin typeface="Helvetica Neue"/>
               </a:rPr>
@@ -3668,7 +3668,7 @@
     <p:bg>
       <p:bgPr>
         <a:solidFill>
-          <a:srgbClr val="07171A"/>
+          <a:srgbClr val="1D1411"/>
         </a:solidFill>
         <a:effectLst/>
       </p:bgPr>
@@ -3695,7 +3695,7 @@
             <a:avLst/>
           </a:prstGeom>
           <a:solidFill>
-            <a:srgbClr val="22D3EE"/>
+            <a:srgbClr val="FF7A5C"/>
           </a:solidFill>
           <a:ln>
             <a:noFill/>
@@ -3750,7 +3750,7 @@
             <a:r>
               <a:rPr sz="1500" b="1">
                 <a:solidFill>
-                  <a:srgbClr val="22D3EE"/>
+                  <a:srgbClr val="FF7A5C"/>
                 </a:solidFill>
                 <a:latin typeface="Helvetica Neue"/>
               </a:rPr>
@@ -3785,7 +3785,7 @@
             <a:r>
               <a:rPr sz="3400" b="1">
                 <a:solidFill>
-                  <a:srgbClr val="D6EEF0"/>
+                  <a:srgbClr val="F7E9E3"/>
                 </a:solidFill>
                 <a:latin typeface="Helvetica Neue"/>
               </a:rPr>
@@ -3809,7 +3809,7 @@
             <a:avLst/>
           </a:prstGeom>
           <a:solidFill>
-            <a:srgbClr val="0F242A"/>
+            <a:srgbClr val="2B1D18"/>
           </a:solidFill>
           <a:ln>
             <a:noFill/>
@@ -3853,7 +3853,7 @@
             <a:avLst/>
           </a:prstGeom>
           <a:solidFill>
-            <a:srgbClr val="22D3EE"/>
+            <a:srgbClr val="FF7A5C"/>
           </a:solidFill>
           <a:ln>
             <a:noFill/>
@@ -3908,7 +3908,7 @@
             <a:r>
               <a:rPr sz="2000" b="1">
                 <a:solidFill>
-                  <a:srgbClr val="22D3EE"/>
+                  <a:srgbClr val="FF7A5C"/>
                 </a:solidFill>
                 <a:latin typeface="Helvetica Neue"/>
               </a:rPr>
@@ -3943,7 +3943,7 @@
             <a:r>
               <a:rPr sz="1500" b="0">
                 <a:solidFill>
-                  <a:srgbClr val="8FB2B6"/>
+                  <a:srgbClr val="BB9A8D"/>
                 </a:solidFill>
                 <a:latin typeface="Helvetica Neue"/>
               </a:rPr>
@@ -3967,7 +3967,7 @@
             <a:avLst/>
           </a:prstGeom>
           <a:solidFill>
-            <a:srgbClr val="0F242A"/>
+            <a:srgbClr val="2B1D18"/>
           </a:solidFill>
           <a:ln>
             <a:noFill/>
@@ -4011,7 +4011,7 @@
             <a:avLst/>
           </a:prstGeom>
           <a:solidFill>
-            <a:srgbClr val="2DD4BF"/>
+            <a:srgbClr val="FFA886"/>
           </a:solidFill>
           <a:ln>
             <a:noFill/>
@@ -4066,7 +4066,7 @@
             <a:r>
               <a:rPr sz="2000" b="1">
                 <a:solidFill>
-                  <a:srgbClr val="2DD4BF"/>
+                  <a:srgbClr val="FFA886"/>
                 </a:solidFill>
                 <a:latin typeface="Helvetica Neue"/>
               </a:rPr>
@@ -4101,7 +4101,7 @@
             <a:r>
               <a:rPr sz="1500" b="0">
                 <a:solidFill>
-                  <a:srgbClr val="8FB2B6"/>
+                  <a:srgbClr val="BB9A8D"/>
                 </a:solidFill>
                 <a:latin typeface="Helvetica Neue"/>
               </a:rPr>
@@ -4125,7 +4125,7 @@
             <a:avLst/>
           </a:prstGeom>
           <a:solidFill>
-            <a:srgbClr val="0F242A"/>
+            <a:srgbClr val="2B1D18"/>
           </a:solidFill>
           <a:ln>
             <a:noFill/>
@@ -4169,7 +4169,7 @@
             <a:avLst/>
           </a:prstGeom>
           <a:solidFill>
-            <a:srgbClr val="5EEAD4"/>
+            <a:srgbClr val="E85A63"/>
           </a:solidFill>
           <a:ln>
             <a:noFill/>
@@ -4224,7 +4224,7 @@
             <a:r>
               <a:rPr sz="2000" b="1">
                 <a:solidFill>
-                  <a:srgbClr val="5EEAD4"/>
+                  <a:srgbClr val="E85A63"/>
                 </a:solidFill>
                 <a:latin typeface="Helvetica Neue"/>
               </a:rPr>
@@ -4259,7 +4259,7 @@
             <a:r>
               <a:rPr sz="1500" b="0">
                 <a:solidFill>
-                  <a:srgbClr val="8FB2B6"/>
+                  <a:srgbClr val="BB9A8D"/>
                 </a:solidFill>
                 <a:latin typeface="Helvetica Neue"/>
               </a:rPr>
@@ -4294,7 +4294,7 @@
             <a:r>
               <a:rPr sz="1800" b="1">
                 <a:solidFill>
-                  <a:srgbClr val="D6EEF0"/>
+                  <a:srgbClr val="F7E9E3"/>
                 </a:solidFill>
                 <a:latin typeface="Helvetica Neue"/>
               </a:rPr>
@@ -4329,7 +4329,7 @@
             <a:r>
               <a:rPr sz="1300" b="1">
                 <a:solidFill>
-                  <a:srgbClr val="8FB2B6"/>
+                  <a:srgbClr val="BB9A8D"/>
                 </a:solidFill>
                 <a:latin typeface="Helvetica Neue"/>
               </a:rPr>
@@ -4364,7 +4364,7 @@
             <a:r>
               <a:rPr sz="1300" b="0">
                 <a:solidFill>
-                  <a:srgbClr val="8FB2B6"/>
+                  <a:srgbClr val="BB9A8D"/>
                 </a:solidFill>
                 <a:latin typeface="Helvetica Neue"/>
               </a:rPr>
@@ -4387,7 +4387,7 @@
     <p:bg>
       <p:bgPr>
         <a:solidFill>
-          <a:srgbClr val="07171A"/>
+          <a:srgbClr val="1D1411"/>
         </a:solidFill>
         <a:effectLst/>
       </p:bgPr>
@@ -4414,7 +4414,7 @@
             <a:avLst/>
           </a:prstGeom>
           <a:solidFill>
-            <a:srgbClr val="2DD4BF"/>
+            <a:srgbClr val="FFA886"/>
           </a:solidFill>
           <a:ln>
             <a:noFill/>
@@ -4469,7 +4469,7 @@
             <a:r>
               <a:rPr sz="1500" b="1">
                 <a:solidFill>
-                  <a:srgbClr val="2DD4BF"/>
+                  <a:srgbClr val="FFA886"/>
                 </a:solidFill>
                 <a:latin typeface="Helvetica Neue"/>
               </a:rPr>
@@ -4504,7 +4504,7 @@
             <a:r>
               <a:rPr sz="3400" b="1">
                 <a:solidFill>
-                  <a:srgbClr val="D6EEF0"/>
+                  <a:srgbClr val="F7E9E3"/>
                 </a:solidFill>
                 <a:latin typeface="Helvetica Neue"/>
               </a:rPr>
@@ -4528,7 +4528,7 @@
             <a:avLst/>
           </a:prstGeom>
           <a:solidFill>
-            <a:srgbClr val="0F242A"/>
+            <a:srgbClr val="2B1D18"/>
           </a:solidFill>
           <a:ln>
             <a:noFill/>
@@ -4583,7 +4583,7 @@
             <a:r>
               <a:rPr sz="1900" b="1">
                 <a:solidFill>
-                  <a:srgbClr val="2DD4BF"/>
+                  <a:srgbClr val="FFA886"/>
                 </a:solidFill>
                 <a:latin typeface="Helvetica Neue"/>
               </a:rPr>
@@ -4618,7 +4618,7 @@
             <a:r>
               <a:rPr sz="1500" b="0">
                 <a:solidFill>
-                  <a:srgbClr val="D6EEF0"/>
+                  <a:srgbClr val="F7E9E3"/>
                 </a:solidFill>
                 <a:latin typeface="Helvetica Neue"/>
               </a:rPr>
@@ -4630,7 +4630,7 @@
             <a:r>
               <a:rPr sz="1500" b="0">
                 <a:solidFill>
-                  <a:srgbClr val="D6EEF0"/>
+                  <a:srgbClr val="F7E9E3"/>
                 </a:solidFill>
                 <a:latin typeface="Helvetica Neue"/>
               </a:rPr>
@@ -4642,7 +4642,7 @@
             <a:r>
               <a:rPr sz="1500" b="0">
                 <a:solidFill>
-                  <a:srgbClr val="D6EEF0"/>
+                  <a:srgbClr val="F7E9E3"/>
                 </a:solidFill>
                 <a:latin typeface="Helvetica Neue"/>
               </a:rPr>
@@ -4654,7 +4654,7 @@
             <a:r>
               <a:rPr sz="1500" b="0">
                 <a:solidFill>
-                  <a:srgbClr val="D6EEF0"/>
+                  <a:srgbClr val="F7E9E3"/>
                 </a:solidFill>
                 <a:latin typeface="Helvetica Neue"/>
               </a:rPr>
@@ -4678,7 +4678,7 @@
             <a:avLst/>
           </a:prstGeom>
           <a:solidFill>
-            <a:srgbClr val="0F242A"/>
+            <a:srgbClr val="2B1D18"/>
           </a:solidFill>
           <a:ln>
             <a:noFill/>
@@ -4733,7 +4733,7 @@
             <a:r>
               <a:rPr sz="1900" b="1">
                 <a:solidFill>
-                  <a:srgbClr val="5EEAD4"/>
+                  <a:srgbClr val="E85A63"/>
                 </a:solidFill>
                 <a:latin typeface="Helvetica Neue"/>
               </a:rPr>
@@ -4768,7 +4768,7 @@
             <a:r>
               <a:rPr sz="1500" b="0">
                 <a:solidFill>
-                  <a:srgbClr val="D6EEF0"/>
+                  <a:srgbClr val="F7E9E3"/>
                 </a:solidFill>
                 <a:latin typeface="Helvetica Neue"/>
               </a:rPr>
@@ -4780,7 +4780,7 @@
             <a:r>
               <a:rPr sz="1500" b="0">
                 <a:solidFill>
-                  <a:srgbClr val="D6EEF0"/>
+                  <a:srgbClr val="F7E9E3"/>
                 </a:solidFill>
                 <a:latin typeface="Helvetica Neue"/>
               </a:rPr>
@@ -4792,7 +4792,7 @@
             <a:r>
               <a:rPr sz="1500" b="0">
                 <a:solidFill>
-                  <a:srgbClr val="D6EEF0"/>
+                  <a:srgbClr val="F7E9E3"/>
                 </a:solidFill>
                 <a:latin typeface="Helvetica Neue"/>
               </a:rPr>
@@ -4804,7 +4804,7 @@
             <a:r>
               <a:rPr sz="1500" b="0">
                 <a:solidFill>
-                  <a:srgbClr val="D6EEF0"/>
+                  <a:srgbClr val="F7E9E3"/>
                 </a:solidFill>
                 <a:latin typeface="Helvetica Neue"/>
               </a:rPr>
@@ -4839,7 +4839,7 @@
             <a:r>
               <a:rPr sz="1800" b="1">
                 <a:solidFill>
-                  <a:srgbClr val="D6EEF0"/>
+                  <a:srgbClr val="F7E9E3"/>
                 </a:solidFill>
                 <a:latin typeface="Helvetica Neue"/>
               </a:rPr>
@@ -4874,7 +4874,7 @@
             <a:r>
               <a:rPr sz="1300" b="1">
                 <a:solidFill>
-                  <a:srgbClr val="8FB2B6"/>
+                  <a:srgbClr val="BB9A8D"/>
                 </a:solidFill>
                 <a:latin typeface="Helvetica Neue"/>
               </a:rPr>
@@ -4909,7 +4909,7 @@
             <a:r>
               <a:rPr sz="1300" b="0">
                 <a:solidFill>
-                  <a:srgbClr val="8FB2B6"/>
+                  <a:srgbClr val="BB9A8D"/>
                 </a:solidFill>
                 <a:latin typeface="Helvetica Neue"/>
               </a:rPr>
@@ -4932,7 +4932,7 @@
     <p:bg>
       <p:bgPr>
         <a:solidFill>
-          <a:srgbClr val="07171A"/>
+          <a:srgbClr val="1D1411"/>
         </a:solidFill>
         <a:effectLst/>
       </p:bgPr>
@@ -4959,7 +4959,7 @@
             <a:avLst/>
           </a:prstGeom>
           <a:solidFill>
-            <a:srgbClr val="5EEAD4"/>
+            <a:srgbClr val="E85A63"/>
           </a:solidFill>
           <a:ln>
             <a:noFill/>
@@ -5014,7 +5014,7 @@
             <a:r>
               <a:rPr sz="1500" b="1">
                 <a:solidFill>
-                  <a:srgbClr val="5EEAD4"/>
+                  <a:srgbClr val="E85A63"/>
                 </a:solidFill>
                 <a:latin typeface="Helvetica Neue"/>
               </a:rPr>
@@ -5049,7 +5049,7 @@
             <a:r>
               <a:rPr sz="3400" b="1">
                 <a:solidFill>
-                  <a:srgbClr val="D6EEF0"/>
+                  <a:srgbClr val="F7E9E3"/>
                 </a:solidFill>
                 <a:latin typeface="Helvetica Neue"/>
               </a:rPr>
@@ -5073,7 +5073,7 @@
             <a:avLst/>
           </a:prstGeom>
           <a:solidFill>
-            <a:srgbClr val="0F242A"/>
+            <a:srgbClr val="2B1D18"/>
           </a:solidFill>
           <a:ln>
             <a:noFill/>
@@ -5117,7 +5117,7 @@
             <a:avLst/>
           </a:prstGeom>
           <a:solidFill>
-            <a:srgbClr val="22D3EE"/>
+            <a:srgbClr val="FF7A5C"/>
           </a:solidFill>
           <a:ln>
             <a:noFill/>
@@ -5172,7 +5172,7 @@
             <a:r>
               <a:rPr sz="2100" b="1">
                 <a:solidFill>
-                  <a:srgbClr val="22D3EE"/>
+                  <a:srgbClr val="FF7A5C"/>
                 </a:solidFill>
                 <a:latin typeface="Helvetica Neue"/>
               </a:rPr>
@@ -5207,7 +5207,7 @@
             <a:r>
               <a:rPr sz="1400" b="0">
                 <a:solidFill>
-                  <a:srgbClr val="8FB2B6"/>
+                  <a:srgbClr val="BB9A8D"/>
                 </a:solidFill>
                 <a:latin typeface="Helvetica Neue"/>
               </a:rPr>
@@ -5242,7 +5242,7 @@
             <a:r>
               <a:rPr sz="1500" b="0">
                 <a:solidFill>
-                  <a:srgbClr val="D6EEF0"/>
+                  <a:srgbClr val="F7E9E3"/>
                 </a:solidFill>
                 <a:latin typeface="Consolas"/>
               </a:rPr>
@@ -5266,7 +5266,7 @@
             <a:avLst/>
           </a:prstGeom>
           <a:solidFill>
-            <a:srgbClr val="0F242A"/>
+            <a:srgbClr val="2B1D18"/>
           </a:solidFill>
           <a:ln>
             <a:noFill/>
@@ -5310,7 +5310,7 @@
             <a:avLst/>
           </a:prstGeom>
           <a:solidFill>
-            <a:srgbClr val="2DD4BF"/>
+            <a:srgbClr val="FFA886"/>
           </a:solidFill>
           <a:ln>
             <a:noFill/>
@@ -5365,7 +5365,7 @@
             <a:r>
               <a:rPr sz="2100" b="1">
                 <a:solidFill>
-                  <a:srgbClr val="2DD4BF"/>
+                  <a:srgbClr val="FFA886"/>
                 </a:solidFill>
                 <a:latin typeface="Helvetica Neue"/>
               </a:rPr>
@@ -5400,7 +5400,7 @@
             <a:r>
               <a:rPr sz="1400" b="0">
                 <a:solidFill>
-                  <a:srgbClr val="8FB2B6"/>
+                  <a:srgbClr val="BB9A8D"/>
                 </a:solidFill>
                 <a:latin typeface="Helvetica Neue"/>
               </a:rPr>
@@ -5435,7 +5435,7 @@
             <a:r>
               <a:rPr sz="1500" b="0">
                 <a:solidFill>
-                  <a:srgbClr val="D6EEF0"/>
+                  <a:srgbClr val="F7E9E3"/>
                 </a:solidFill>
                 <a:latin typeface="Consolas"/>
               </a:rPr>
@@ -5459,7 +5459,7 @@
             <a:avLst/>
           </a:prstGeom>
           <a:solidFill>
-            <a:srgbClr val="0F242A"/>
+            <a:srgbClr val="2B1D18"/>
           </a:solidFill>
           <a:ln>
             <a:noFill/>
@@ -5503,7 +5503,7 @@
             <a:avLst/>
           </a:prstGeom>
           <a:solidFill>
-            <a:srgbClr val="5EEAD4"/>
+            <a:srgbClr val="E85A63"/>
           </a:solidFill>
           <a:ln>
             <a:noFill/>
@@ -5558,7 +5558,7 @@
             <a:r>
               <a:rPr sz="2100" b="1">
                 <a:solidFill>
-                  <a:srgbClr val="5EEAD4"/>
+                  <a:srgbClr val="E85A63"/>
                 </a:solidFill>
                 <a:latin typeface="Helvetica Neue"/>
               </a:rPr>
@@ -5593,7 +5593,7 @@
             <a:r>
               <a:rPr sz="1400" b="0">
                 <a:solidFill>
-                  <a:srgbClr val="8FB2B6"/>
+                  <a:srgbClr val="BB9A8D"/>
                 </a:solidFill>
                 <a:latin typeface="Helvetica Neue"/>
               </a:rPr>
@@ -5628,7 +5628,7 @@
             <a:r>
               <a:rPr sz="1500" b="0">
                 <a:solidFill>
-                  <a:srgbClr val="D6EEF0"/>
+                  <a:srgbClr val="F7E9E3"/>
                 </a:solidFill>
                 <a:latin typeface="Consolas"/>
               </a:rPr>
@@ -5663,7 +5663,7 @@
             <a:r>
               <a:rPr sz="1300" b="1">
                 <a:solidFill>
-                  <a:srgbClr val="8FB2B6"/>
+                  <a:srgbClr val="BB9A8D"/>
                 </a:solidFill>
                 <a:latin typeface="Helvetica Neue"/>
               </a:rPr>
@@ -5698,7 +5698,7 @@
             <a:r>
               <a:rPr sz="1300" b="0">
                 <a:solidFill>
-                  <a:srgbClr val="8FB2B6"/>
+                  <a:srgbClr val="BB9A8D"/>
                 </a:solidFill>
                 <a:latin typeface="Helvetica Neue"/>
               </a:rPr>
@@ -5721,7 +5721,7 @@
     <p:bg>
       <p:bgPr>
         <a:solidFill>
-          <a:srgbClr val="07171A"/>
+          <a:srgbClr val="1D1411"/>
         </a:solidFill>
         <a:effectLst/>
       </p:bgPr>
@@ -5748,7 +5748,7 @@
             <a:avLst/>
           </a:prstGeom>
           <a:solidFill>
-            <a:srgbClr val="67E8F9"/>
+            <a:srgbClr val="FFC89E"/>
           </a:solidFill>
           <a:ln>
             <a:noFill/>
@@ -5803,7 +5803,7 @@
             <a:r>
               <a:rPr sz="1500" b="1">
                 <a:solidFill>
-                  <a:srgbClr val="67E8F9"/>
+                  <a:srgbClr val="FFC89E"/>
                 </a:solidFill>
                 <a:latin typeface="Helvetica Neue"/>
               </a:rPr>
@@ -5838,7 +5838,7 @@
             <a:r>
               <a:rPr sz="3400" b="1">
                 <a:solidFill>
-                  <a:srgbClr val="D6EEF0"/>
+                  <a:srgbClr val="F7E9E3"/>
                 </a:solidFill>
                 <a:latin typeface="Helvetica Neue"/>
               </a:rPr>
@@ -5873,7 +5873,7 @@
             <a:r>
               <a:rPr sz="1500" b="0">
                 <a:solidFill>
-                  <a:srgbClr val="8FB2B6"/>
+                  <a:srgbClr val="BB9A8D"/>
                 </a:solidFill>
                 <a:latin typeface="Helvetica Neue"/>
               </a:rPr>
@@ -5897,7 +5897,7 @@
             <a:avLst/>
           </a:prstGeom>
           <a:solidFill>
-            <a:srgbClr val="0F242A"/>
+            <a:srgbClr val="2B1D18"/>
           </a:solidFill>
           <a:ln>
             <a:noFill/>
@@ -5952,7 +5952,7 @@
             <a:r>
               <a:rPr sz="5400" b="1">
                 <a:solidFill>
-                  <a:srgbClr val="22D3EE"/>
+                  <a:srgbClr val="FF7A5C"/>
                 </a:solidFill>
                 <a:latin typeface="Helvetica Neue"/>
               </a:rPr>
@@ -5987,7 +5987,7 @@
             <a:r>
               <a:rPr sz="1800" b="1">
                 <a:solidFill>
-                  <a:srgbClr val="D6EEF0"/>
+                  <a:srgbClr val="F7E9E3"/>
                 </a:solidFill>
                 <a:latin typeface="Helvetica Neue"/>
               </a:rPr>
@@ -6022,7 +6022,7 @@
             <a:r>
               <a:rPr sz="1300" b="0">
                 <a:solidFill>
-                  <a:srgbClr val="8FB2B6"/>
+                  <a:srgbClr val="BB9A8D"/>
                 </a:solidFill>
                 <a:latin typeface="Helvetica Neue"/>
               </a:rPr>
@@ -6046,7 +6046,7 @@
             <a:avLst/>
           </a:prstGeom>
           <a:solidFill>
-            <a:srgbClr val="0F242A"/>
+            <a:srgbClr val="2B1D18"/>
           </a:solidFill>
           <a:ln>
             <a:noFill/>
@@ -6101,7 +6101,7 @@
             <a:r>
               <a:rPr sz="5400" b="1">
                 <a:solidFill>
-                  <a:srgbClr val="2DD4BF"/>
+                  <a:srgbClr val="FFA886"/>
                 </a:solidFill>
                 <a:latin typeface="Helvetica Neue"/>
               </a:rPr>
@@ -6136,7 +6136,7 @@
             <a:r>
               <a:rPr sz="1800" b="1">
                 <a:solidFill>
-                  <a:srgbClr val="D6EEF0"/>
+                  <a:srgbClr val="F7E9E3"/>
                 </a:solidFill>
                 <a:latin typeface="Helvetica Neue"/>
               </a:rPr>
@@ -6171,7 +6171,7 @@
             <a:r>
               <a:rPr sz="1300" b="0">
                 <a:solidFill>
-                  <a:srgbClr val="8FB2B6"/>
+                  <a:srgbClr val="BB9A8D"/>
                 </a:solidFill>
                 <a:latin typeface="Helvetica Neue"/>
               </a:rPr>
@@ -6195,7 +6195,7 @@
             <a:avLst/>
           </a:prstGeom>
           <a:solidFill>
-            <a:srgbClr val="0F242A"/>
+            <a:srgbClr val="2B1D18"/>
           </a:solidFill>
           <a:ln>
             <a:noFill/>
@@ -6250,7 +6250,7 @@
             <a:r>
               <a:rPr sz="5400" b="1">
                 <a:solidFill>
-                  <a:srgbClr val="5EEAD4"/>
+                  <a:srgbClr val="E85A63"/>
                 </a:solidFill>
                 <a:latin typeface="Helvetica Neue"/>
               </a:rPr>
@@ -6285,7 +6285,7 @@
             <a:r>
               <a:rPr sz="1800" b="1">
                 <a:solidFill>
-                  <a:srgbClr val="D6EEF0"/>
+                  <a:srgbClr val="F7E9E3"/>
                 </a:solidFill>
                 <a:latin typeface="Helvetica Neue"/>
               </a:rPr>
@@ -6320,7 +6320,7 @@
             <a:r>
               <a:rPr sz="1300" b="0">
                 <a:solidFill>
-                  <a:srgbClr val="8FB2B6"/>
+                  <a:srgbClr val="BB9A8D"/>
                 </a:solidFill>
                 <a:latin typeface="Helvetica Neue"/>
               </a:rPr>
@@ -6344,7 +6344,7 @@
             <a:avLst/>
           </a:prstGeom>
           <a:solidFill>
-            <a:srgbClr val="0F242A"/>
+            <a:srgbClr val="2B1D18"/>
           </a:solidFill>
           <a:ln>
             <a:noFill/>
@@ -6399,7 +6399,7 @@
             <a:r>
               <a:rPr sz="5400" b="1">
                 <a:solidFill>
-                  <a:srgbClr val="67E8F9"/>
+                  <a:srgbClr val="FFC89E"/>
                 </a:solidFill>
                 <a:latin typeface="Helvetica Neue"/>
               </a:rPr>
@@ -6434,7 +6434,7 @@
             <a:r>
               <a:rPr sz="1800" b="1">
                 <a:solidFill>
-                  <a:srgbClr val="D6EEF0"/>
+                  <a:srgbClr val="F7E9E3"/>
                 </a:solidFill>
                 <a:latin typeface="Helvetica Neue"/>
               </a:rPr>
@@ -6469,7 +6469,7 @@
             <a:r>
               <a:rPr sz="1300" b="0">
                 <a:solidFill>
-                  <a:srgbClr val="8FB2B6"/>
+                  <a:srgbClr val="BB9A8D"/>
                 </a:solidFill>
                 <a:latin typeface="Helvetica Neue"/>
               </a:rPr>
@@ -6493,7 +6493,7 @@
             <a:avLst/>
           </a:prstGeom>
           <a:solidFill>
-            <a:srgbClr val="0F242A"/>
+            <a:srgbClr val="2B1D18"/>
           </a:solidFill>
           <a:ln>
             <a:noFill/>
@@ -6548,7 +6548,7 @@
             <a:r>
               <a:rPr sz="5400" b="1">
                 <a:solidFill>
-                  <a:srgbClr val="22D3EE"/>
+                  <a:srgbClr val="FF7A5C"/>
                 </a:solidFill>
                 <a:latin typeface="Helvetica Neue"/>
               </a:rPr>
@@ -6583,7 +6583,7 @@
             <a:r>
               <a:rPr sz="1800" b="1">
                 <a:solidFill>
-                  <a:srgbClr val="D6EEF0"/>
+                  <a:srgbClr val="F7E9E3"/>
                 </a:solidFill>
                 <a:latin typeface="Helvetica Neue"/>
               </a:rPr>
@@ -6618,7 +6618,7 @@
             <a:r>
               <a:rPr sz="1300" b="0">
                 <a:solidFill>
-                  <a:srgbClr val="8FB2B6"/>
+                  <a:srgbClr val="BB9A8D"/>
                 </a:solidFill>
                 <a:latin typeface="Helvetica Neue"/>
               </a:rPr>
@@ -6653,7 +6653,7 @@
             <a:r>
               <a:rPr sz="1700" b="1">
                 <a:solidFill>
-                  <a:srgbClr val="2DD4BF"/>
+                  <a:srgbClr val="FFA886"/>
                 </a:solidFill>
                 <a:latin typeface="Consolas"/>
               </a:rPr>
@@ -6688,7 +6688,7 @@
             <a:r>
               <a:rPr sz="1500" b="0">
                 <a:solidFill>
-                  <a:srgbClr val="8FB2B6"/>
+                  <a:srgbClr val="BB9A8D"/>
                 </a:solidFill>
                 <a:latin typeface="Helvetica Neue"/>
               </a:rPr>
@@ -6723,7 +6723,7 @@
             <a:r>
               <a:rPr sz="1300" b="1">
                 <a:solidFill>
-                  <a:srgbClr val="8FB2B6"/>
+                  <a:srgbClr val="BB9A8D"/>
                 </a:solidFill>
                 <a:latin typeface="Helvetica Neue"/>
               </a:rPr>
@@ -6758,7 +6758,7 @@
             <a:r>
               <a:rPr sz="1300" b="0">
                 <a:solidFill>
-                  <a:srgbClr val="8FB2B6"/>
+                  <a:srgbClr val="BB9A8D"/>
                 </a:solidFill>
                 <a:latin typeface="Helvetica Neue"/>
               </a:rPr>
@@ -6781,7 +6781,7 @@
     <p:bg>
       <p:bgPr>
         <a:solidFill>
-          <a:srgbClr val="07171A"/>
+          <a:srgbClr val="1D1411"/>
         </a:solidFill>
         <a:effectLst/>
       </p:bgPr>
@@ -6808,7 +6808,7 @@
             <a:avLst/>
           </a:prstGeom>
           <a:solidFill>
-            <a:srgbClr val="22D3EE"/>
+            <a:srgbClr val="FF7A5C"/>
           </a:solidFill>
           <a:ln>
             <a:noFill/>
@@ -6863,7 +6863,7 @@
             <a:r>
               <a:rPr sz="1500" b="1">
                 <a:solidFill>
-                  <a:srgbClr val="22D3EE"/>
+                  <a:srgbClr val="FF7A5C"/>
                 </a:solidFill>
                 <a:latin typeface="Helvetica Neue"/>
               </a:rPr>
@@ -6898,7 +6898,7 @@
             <a:r>
               <a:rPr sz="3400" b="1">
                 <a:solidFill>
-                  <a:srgbClr val="D6EEF0"/>
+                  <a:srgbClr val="F7E9E3"/>
                 </a:solidFill>
                 <a:latin typeface="Helvetica Neue"/>
               </a:rPr>
@@ -6922,7 +6922,7 @@
             <a:avLst/>
           </a:prstGeom>
           <a:solidFill>
-            <a:srgbClr val="0F242A"/>
+            <a:srgbClr val="2B1D18"/>
           </a:solidFill>
           <a:ln>
             <a:noFill/>
@@ -6977,7 +6977,7 @@
             <a:r>
               <a:rPr sz="1500" b="1">
                 <a:solidFill>
-                  <a:srgbClr val="22D3EE"/>
+                  <a:srgbClr val="FF7A5C"/>
                 </a:solidFill>
                 <a:latin typeface="Helvetica Neue"/>
               </a:rPr>
@@ -7012,7 +7012,7 @@
             <a:r>
               <a:rPr sz="1500" b="0">
                 <a:solidFill>
-                  <a:srgbClr val="D6EEF0"/>
+                  <a:srgbClr val="F7E9E3"/>
                 </a:solidFill>
                 <a:latin typeface="Consolas"/>
               </a:rPr>
@@ -7024,7 +7024,7 @@
             <a:r>
               <a:rPr sz="1500" b="0">
                 <a:solidFill>
-                  <a:srgbClr val="D6EEF0"/>
+                  <a:srgbClr val="F7E9E3"/>
                 </a:solidFill>
                 <a:latin typeface="Consolas"/>
               </a:rPr>
@@ -7036,7 +7036,7 @@
             <a:r>
               <a:rPr sz="1500" b="0">
                 <a:solidFill>
-                  <a:srgbClr val="D6EEF0"/>
+                  <a:srgbClr val="F7E9E3"/>
                 </a:solidFill>
                 <a:latin typeface="Consolas"/>
               </a:rPr>
@@ -7060,7 +7060,7 @@
             <a:avLst/>
           </a:prstGeom>
           <a:solidFill>
-            <a:srgbClr val="0F242A"/>
+            <a:srgbClr val="2B1D18"/>
           </a:solidFill>
           <a:ln>
             <a:noFill/>
@@ -7115,7 +7115,7 @@
             <a:r>
               <a:rPr sz="1500" b="1">
                 <a:solidFill>
-                  <a:srgbClr val="2DD4BF"/>
+                  <a:srgbClr val="FFA886"/>
                 </a:solidFill>
                 <a:latin typeface="Helvetica Neue"/>
               </a:rPr>
@@ -7150,7 +7150,7 @@
             <a:r>
               <a:rPr sz="1500" b="0">
                 <a:solidFill>
-                  <a:srgbClr val="D6EEF0"/>
+                  <a:srgbClr val="F7E9E3"/>
                 </a:solidFill>
                 <a:latin typeface="Consolas"/>
               </a:rPr>
@@ -7162,7 +7162,7 @@
             <a:r>
               <a:rPr sz="1500" b="0">
                 <a:solidFill>
-                  <a:srgbClr val="D6EEF0"/>
+                  <a:srgbClr val="F7E9E3"/>
                 </a:solidFill>
                 <a:latin typeface="Consolas"/>
               </a:rPr>
@@ -7174,7 +7174,7 @@
             <a:r>
               <a:rPr sz="1500" b="0">
                 <a:solidFill>
-                  <a:srgbClr val="D6EEF0"/>
+                  <a:srgbClr val="F7E9E3"/>
                 </a:solidFill>
                 <a:latin typeface="Consolas"/>
               </a:rPr>
@@ -7198,7 +7198,7 @@
             <a:avLst/>
           </a:prstGeom>
           <a:solidFill>
-            <a:srgbClr val="0F242A"/>
+            <a:srgbClr val="2B1D18"/>
           </a:solidFill>
           <a:ln>
             <a:noFill/>
@@ -7253,7 +7253,7 @@
             <a:r>
               <a:rPr sz="1500" b="1">
                 <a:solidFill>
-                  <a:srgbClr val="5EEAD4"/>
+                  <a:srgbClr val="E85A63"/>
                 </a:solidFill>
                 <a:latin typeface="Helvetica Neue"/>
               </a:rPr>
@@ -7288,7 +7288,7 @@
             <a:r>
               <a:rPr sz="1500" b="0">
                 <a:solidFill>
-                  <a:srgbClr val="D6EEF0"/>
+                  <a:srgbClr val="F7E9E3"/>
                 </a:solidFill>
                 <a:latin typeface="Consolas"/>
               </a:rPr>
@@ -7300,7 +7300,7 @@
             <a:r>
               <a:rPr sz="1500" b="0">
                 <a:solidFill>
-                  <a:srgbClr val="D6EEF0"/>
+                  <a:srgbClr val="F7E9E3"/>
                 </a:solidFill>
                 <a:latin typeface="Consolas"/>
               </a:rPr>
@@ -7312,7 +7312,7 @@
             <a:r>
               <a:rPr sz="1500" b="0">
                 <a:solidFill>
-                  <a:srgbClr val="D6EEF0"/>
+                  <a:srgbClr val="F7E9E3"/>
                 </a:solidFill>
                 <a:latin typeface="Consolas"/>
               </a:rPr>
@@ -7336,7 +7336,7 @@
             <a:avLst/>
           </a:prstGeom>
           <a:solidFill>
-            <a:srgbClr val="0F242A"/>
+            <a:srgbClr val="2B1D18"/>
           </a:solidFill>
           <a:ln>
             <a:noFill/>
@@ -7391,7 +7391,7 @@
             <a:r>
               <a:rPr sz="1500" b="1">
                 <a:solidFill>
-                  <a:srgbClr val="67E8F9"/>
+                  <a:srgbClr val="FFC89E"/>
                 </a:solidFill>
                 <a:latin typeface="Helvetica Neue"/>
               </a:rPr>
@@ -7426,7 +7426,7 @@
             <a:r>
               <a:rPr sz="1500" b="0">
                 <a:solidFill>
-                  <a:srgbClr val="D6EEF0"/>
+                  <a:srgbClr val="F7E9E3"/>
                 </a:solidFill>
                 <a:latin typeface="Consolas"/>
               </a:rPr>
@@ -7438,7 +7438,7 @@
             <a:r>
               <a:rPr sz="1500" b="0">
                 <a:solidFill>
-                  <a:srgbClr val="D6EEF0"/>
+                  <a:srgbClr val="F7E9E3"/>
                 </a:solidFill>
                 <a:latin typeface="Consolas"/>
               </a:rPr>
@@ -7450,7 +7450,7 @@
             <a:r>
               <a:rPr sz="1500" b="0">
                 <a:solidFill>
-                  <a:srgbClr val="D6EEF0"/>
+                  <a:srgbClr val="F7E9E3"/>
                 </a:solidFill>
                 <a:latin typeface="Consolas"/>
               </a:rPr>
@@ -7485,7 +7485,7 @@
             <a:r>
               <a:rPr sz="1400" b="0">
                 <a:solidFill>
-                  <a:srgbClr val="8FB2B6"/>
+                  <a:srgbClr val="BB9A8D"/>
                 </a:solidFill>
                 <a:latin typeface="Helvetica Neue"/>
               </a:rPr>
@@ -7520,7 +7520,7 @@
             <a:r>
               <a:rPr sz="1300" b="1">
                 <a:solidFill>
-                  <a:srgbClr val="8FB2B6"/>
+                  <a:srgbClr val="BB9A8D"/>
                 </a:solidFill>
                 <a:latin typeface="Helvetica Neue"/>
               </a:rPr>
@@ -7555,7 +7555,7 @@
             <a:r>
               <a:rPr sz="1300" b="0">
                 <a:solidFill>
-                  <a:srgbClr val="8FB2B6"/>
+                  <a:srgbClr val="BB9A8D"/>
                 </a:solidFill>
                 <a:latin typeface="Helvetica Neue"/>
               </a:rPr>
@@ -7578,7 +7578,7 @@
     <p:bg>
       <p:bgPr>
         <a:solidFill>
-          <a:srgbClr val="07171A"/>
+          <a:srgbClr val="1D1411"/>
         </a:solidFill>
         <a:effectLst/>
       </p:bgPr>
@@ -7605,7 +7605,7 @@
             <a:avLst/>
           </a:prstGeom>
           <a:solidFill>
-            <a:srgbClr val="2DD4BF"/>
+            <a:srgbClr val="FFA886"/>
           </a:solidFill>
           <a:ln>
             <a:noFill/>
@@ -7660,7 +7660,7 @@
             <a:r>
               <a:rPr sz="1500" b="1">
                 <a:solidFill>
-                  <a:srgbClr val="2DD4BF"/>
+                  <a:srgbClr val="FFA886"/>
                 </a:solidFill>
                 <a:latin typeface="Helvetica Neue"/>
               </a:rPr>
@@ -7695,7 +7695,7 @@
             <a:r>
               <a:rPr sz="3400" b="1">
                 <a:solidFill>
-                  <a:srgbClr val="D6EEF0"/>
+                  <a:srgbClr val="F7E9E3"/>
                 </a:solidFill>
                 <a:latin typeface="Helvetica Neue"/>
               </a:rPr>
@@ -7719,7 +7719,7 @@
             <a:avLst/>
           </a:prstGeom>
           <a:solidFill>
-            <a:srgbClr val="0F242A"/>
+            <a:srgbClr val="2B1D18"/>
           </a:solidFill>
           <a:ln>
             <a:noFill/>
@@ -7763,7 +7763,7 @@
             <a:avLst/>
           </a:prstGeom>
           <a:solidFill>
-            <a:srgbClr val="22D3EE"/>
+            <a:srgbClr val="FF7A5C"/>
           </a:solidFill>
           <a:ln>
             <a:noFill/>
@@ -7818,7 +7818,7 @@
             <a:r>
               <a:rPr sz="1900" b="1">
                 <a:solidFill>
-                  <a:srgbClr val="22D3EE"/>
+                  <a:srgbClr val="FF7A5C"/>
                 </a:solidFill>
                 <a:latin typeface="Helvetica Neue"/>
               </a:rPr>
@@ -7853,7 +7853,7 @@
             <a:r>
               <a:rPr sz="1400" b="0">
                 <a:solidFill>
-                  <a:srgbClr val="8FB2B6"/>
+                  <a:srgbClr val="BB9A8D"/>
                 </a:solidFill>
                 <a:latin typeface="Helvetica Neue"/>
               </a:rPr>
@@ -7888,7 +7888,7 @@
             <a:r>
               <a:rPr sz="1500" b="0">
                 <a:solidFill>
-                  <a:srgbClr val="D6EEF0"/>
+                  <a:srgbClr val="F7E9E3"/>
                 </a:solidFill>
                 <a:latin typeface="Consolas"/>
               </a:rPr>
@@ -7912,7 +7912,7 @@
             <a:avLst/>
           </a:prstGeom>
           <a:solidFill>
-            <a:srgbClr val="0F242A"/>
+            <a:srgbClr val="2B1D18"/>
           </a:solidFill>
           <a:ln>
             <a:noFill/>
@@ -7956,7 +7956,7 @@
             <a:avLst/>
           </a:prstGeom>
           <a:solidFill>
-            <a:srgbClr val="5EEAD4"/>
+            <a:srgbClr val="E85A63"/>
           </a:solidFill>
           <a:ln>
             <a:noFill/>
@@ -8011,7 +8011,7 @@
             <a:r>
               <a:rPr sz="1900" b="1">
                 <a:solidFill>
-                  <a:srgbClr val="5EEAD4"/>
+                  <a:srgbClr val="E85A63"/>
                 </a:solidFill>
                 <a:latin typeface="Helvetica Neue"/>
               </a:rPr>
@@ -8046,7 +8046,7 @@
             <a:r>
               <a:rPr sz="1400" b="0">
                 <a:solidFill>
-                  <a:srgbClr val="8FB2B6"/>
+                  <a:srgbClr val="BB9A8D"/>
                 </a:solidFill>
                 <a:latin typeface="Helvetica Neue"/>
               </a:rPr>
@@ -8081,7 +8081,7 @@
             <a:r>
               <a:rPr sz="1500" b="0">
                 <a:solidFill>
-                  <a:srgbClr val="D6EEF0"/>
+                  <a:srgbClr val="F7E9E3"/>
                 </a:solidFill>
                 <a:latin typeface="Consolas"/>
               </a:rPr>
@@ -8105,7 +8105,7 @@
             <a:avLst/>
           </a:prstGeom>
           <a:solidFill>
-            <a:srgbClr val="0F242A"/>
+            <a:srgbClr val="2B1D18"/>
           </a:solidFill>
           <a:ln>
             <a:noFill/>
@@ -8149,7 +8149,7 @@
             <a:avLst/>
           </a:prstGeom>
           <a:solidFill>
-            <a:srgbClr val="67E8F9"/>
+            <a:srgbClr val="FFC89E"/>
           </a:solidFill>
           <a:ln>
             <a:noFill/>
@@ -8204,7 +8204,7 @@
             <a:r>
               <a:rPr sz="1900" b="1">
                 <a:solidFill>
-                  <a:srgbClr val="67E8F9"/>
+                  <a:srgbClr val="FFC89E"/>
                 </a:solidFill>
                 <a:latin typeface="Helvetica Neue"/>
               </a:rPr>
@@ -8239,7 +8239,7 @@
             <a:r>
               <a:rPr sz="1400" b="0">
                 <a:solidFill>
-                  <a:srgbClr val="8FB2B6"/>
+                  <a:srgbClr val="BB9A8D"/>
                 </a:solidFill>
                 <a:latin typeface="Helvetica Neue"/>
               </a:rPr>
@@ -8274,7 +8274,7 @@
             <a:r>
               <a:rPr sz="1500" b="0">
                 <a:solidFill>
-                  <a:srgbClr val="D6EEF0"/>
+                  <a:srgbClr val="F7E9E3"/>
                 </a:solidFill>
                 <a:latin typeface="Consolas"/>
               </a:rPr>
@@ -8309,7 +8309,7 @@
             <a:r>
               <a:rPr sz="1300" b="1">
                 <a:solidFill>
-                  <a:srgbClr val="8FB2B6"/>
+                  <a:srgbClr val="BB9A8D"/>
                 </a:solidFill>
                 <a:latin typeface="Helvetica Neue"/>
               </a:rPr>
@@ -8344,7 +8344,7 @@
             <a:r>
               <a:rPr sz="1300" b="0">
                 <a:solidFill>
-                  <a:srgbClr val="8FB2B6"/>
+                  <a:srgbClr val="BB9A8D"/>
                 </a:solidFill>
                 <a:latin typeface="Helvetica Neue"/>
               </a:rPr>
@@ -8367,7 +8367,7 @@
     <p:bg>
       <p:bgPr>
         <a:solidFill>
-          <a:srgbClr val="07171A"/>
+          <a:srgbClr val="1D1411"/>
         </a:solidFill>
         <a:effectLst/>
       </p:bgPr>
@@ -8394,7 +8394,7 @@
             <a:avLst/>
           </a:prstGeom>
           <a:solidFill>
-            <a:srgbClr val="2DD4BF"/>
+            <a:srgbClr val="FFA886"/>
           </a:solidFill>
           <a:ln>
             <a:noFill/>
@@ -8449,7 +8449,7 @@
             <a:r>
               <a:rPr sz="1500" b="1">
                 <a:solidFill>
-                  <a:srgbClr val="2DD4BF"/>
+                  <a:srgbClr val="FFA886"/>
                 </a:solidFill>
                 <a:latin typeface="Helvetica Neue"/>
               </a:rPr>
@@ -8484,7 +8484,7 @@
             <a:r>
               <a:rPr sz="3400" b="1">
                 <a:solidFill>
-                  <a:srgbClr val="D6EEF0"/>
+                  <a:srgbClr val="F7E9E3"/>
                 </a:solidFill>
                 <a:latin typeface="Helvetica Neue"/>
               </a:rPr>
@@ -8519,7 +8519,7 @@
             <a:r>
               <a:rPr sz="1500" b="0">
                 <a:solidFill>
-                  <a:srgbClr val="8FB2B6"/>
+                  <a:srgbClr val="BB9A8D"/>
                 </a:solidFill>
                 <a:latin typeface="Consolas"/>
               </a:rPr>
@@ -8543,7 +8543,7 @@
             <a:avLst/>
           </a:prstGeom>
           <a:solidFill>
-            <a:srgbClr val="0F242A"/>
+            <a:srgbClr val="2B1D18"/>
           </a:solidFill>
           <a:ln>
             <a:noFill/>
@@ -8587,7 +8587,7 @@
             <a:avLst/>
           </a:prstGeom>
           <a:solidFill>
-            <a:srgbClr val="22D3EE"/>
+            <a:srgbClr val="FF7A5C"/>
           </a:solidFill>
           <a:ln>
             <a:noFill/>
@@ -8642,7 +8642,7 @@
             <a:r>
               <a:rPr sz="1800" b="1">
                 <a:solidFill>
-                  <a:srgbClr val="22D3EE"/>
+                  <a:srgbClr val="FF7A5C"/>
                 </a:solidFill>
                 <a:latin typeface="Helvetica Neue"/>
               </a:rPr>
@@ -8677,7 +8677,7 @@
             <a:r>
               <a:rPr sz="1400" b="0">
                 <a:solidFill>
-                  <a:srgbClr val="D6EEF0"/>
+                  <a:srgbClr val="F7E9E3"/>
                 </a:solidFill>
                 <a:latin typeface="Consolas"/>
               </a:rPr>
@@ -8712,7 +8712,7 @@
             <a:r>
               <a:rPr sz="1400" b="0">
                 <a:solidFill>
-                  <a:srgbClr val="8FB2B6"/>
+                  <a:srgbClr val="BB9A8D"/>
                 </a:solidFill>
                 <a:latin typeface="Consolas"/>
               </a:rPr>
@@ -8736,7 +8736,7 @@
             <a:avLst/>
           </a:prstGeom>
           <a:solidFill>
-            <a:srgbClr val="0F242A"/>
+            <a:srgbClr val="2B1D18"/>
           </a:solidFill>
           <a:ln>
             <a:noFill/>
@@ -8780,7 +8780,7 @@
             <a:avLst/>
           </a:prstGeom>
           <a:solidFill>
-            <a:srgbClr val="5EEAD4"/>
+            <a:srgbClr val="E85A63"/>
           </a:solidFill>
           <a:ln>
             <a:noFill/>
@@ -8835,7 +8835,7 @@
             <a:r>
               <a:rPr sz="1800" b="1">
                 <a:solidFill>
-                  <a:srgbClr val="5EEAD4"/>
+                  <a:srgbClr val="E85A63"/>
                 </a:solidFill>
                 <a:latin typeface="Helvetica Neue"/>
               </a:rPr>
@@ -8870,7 +8870,7 @@
             <a:r>
               <a:rPr sz="1400" b="0">
                 <a:solidFill>
-                  <a:srgbClr val="D6EEF0"/>
+                  <a:srgbClr val="F7E9E3"/>
                 </a:solidFill>
                 <a:latin typeface="Consolas"/>
               </a:rPr>
@@ -8905,7 +8905,7 @@
             <a:r>
               <a:rPr sz="1400" b="0">
                 <a:solidFill>
-                  <a:srgbClr val="8FB2B6"/>
+                  <a:srgbClr val="BB9A8D"/>
                 </a:solidFill>
                 <a:latin typeface="Consolas"/>
               </a:rPr>
@@ -8929,7 +8929,7 @@
             <a:avLst/>
           </a:prstGeom>
           <a:solidFill>
-            <a:srgbClr val="0F242A"/>
+            <a:srgbClr val="2B1D18"/>
           </a:solidFill>
           <a:ln>
             <a:noFill/>
@@ -8973,7 +8973,7 @@
             <a:avLst/>
           </a:prstGeom>
           <a:solidFill>
-            <a:srgbClr val="67E8F9"/>
+            <a:srgbClr val="FFC89E"/>
           </a:solidFill>
           <a:ln>
             <a:noFill/>
@@ -9028,7 +9028,7 @@
             <a:r>
               <a:rPr sz="1800" b="1">
                 <a:solidFill>
-                  <a:srgbClr val="67E8F9"/>
+                  <a:srgbClr val="FFC89E"/>
                 </a:solidFill>
                 <a:latin typeface="Helvetica Neue"/>
               </a:rPr>
@@ -9063,7 +9063,7 @@
             <a:r>
               <a:rPr sz="1400" b="0">
                 <a:solidFill>
-                  <a:srgbClr val="D6EEF0"/>
+                  <a:srgbClr val="F7E9E3"/>
                 </a:solidFill>
                 <a:latin typeface="Consolas"/>
               </a:rPr>
@@ -9098,7 +9098,7 @@
             <a:r>
               <a:rPr sz="1400" b="0">
                 <a:solidFill>
-                  <a:srgbClr val="8FB2B6"/>
+                  <a:srgbClr val="BB9A8D"/>
                 </a:solidFill>
                 <a:latin typeface="Consolas"/>
               </a:rPr>
@@ -9122,7 +9122,7 @@
             <a:avLst/>
           </a:prstGeom>
           <a:solidFill>
-            <a:srgbClr val="0B2026"/>
+            <a:srgbClr val="241712"/>
           </a:solidFill>
           <a:ln>
             <a:noFill/>
@@ -9177,7 +9177,7 @@
             <a:r>
               <a:rPr sz="1600" b="1">
                 <a:solidFill>
-                  <a:srgbClr val="2DD4BF"/>
+                  <a:srgbClr val="FFA886"/>
                 </a:solidFill>
                 <a:latin typeface="Helvetica Neue"/>
               </a:rPr>
@@ -9212,7 +9212,7 @@
             <a:r>
               <a:rPr sz="1500" b="0">
                 <a:solidFill>
-                  <a:srgbClr val="D6EEF0"/>
+                  <a:srgbClr val="F7E9E3"/>
                 </a:solidFill>
                 <a:latin typeface="Consolas"/>
               </a:rPr>
@@ -9247,7 +9247,7 @@
             <a:r>
               <a:rPr sz="1500" b="0">
                 <a:solidFill>
-                  <a:srgbClr val="D6EEF0"/>
+                  <a:srgbClr val="F7E9E3"/>
                 </a:solidFill>
                 <a:latin typeface="Consolas"/>
               </a:rPr>
@@ -9282,7 +9282,7 @@
             <a:r>
               <a:rPr sz="1600" b="1">
                 <a:solidFill>
-                  <a:srgbClr val="D6EEF0"/>
+                  <a:srgbClr val="F7E9E3"/>
                 </a:solidFill>
                 <a:latin typeface="Helvetica Neue"/>
               </a:rPr>
@@ -9317,7 +9317,7 @@
             <a:r>
               <a:rPr sz="1300" b="1">
                 <a:solidFill>
-                  <a:srgbClr val="8FB2B6"/>
+                  <a:srgbClr val="BB9A8D"/>
                 </a:solidFill>
                 <a:latin typeface="Helvetica Neue"/>
               </a:rPr>
@@ -9352,7 +9352,7 @@
             <a:r>
               <a:rPr sz="1300" b="0">
                 <a:solidFill>
-                  <a:srgbClr val="8FB2B6"/>
+                  <a:srgbClr val="BB9A8D"/>
                 </a:solidFill>
                 <a:latin typeface="Helvetica Neue"/>
               </a:rPr>
@@ -9375,7 +9375,7 @@
     <p:bg>
       <p:bgPr>
         <a:solidFill>
-          <a:srgbClr val="07171A"/>
+          <a:srgbClr val="1D1411"/>
         </a:solidFill>
         <a:effectLst/>
       </p:bgPr>
@@ -9402,7 +9402,7 @@
             <a:avLst/>
           </a:prstGeom>
           <a:solidFill>
-            <a:srgbClr val="5EEAD4"/>
+            <a:srgbClr val="E85A63"/>
           </a:solidFill>
           <a:ln>
             <a:noFill/>
@@ -9457,7 +9457,7 @@
             <a:r>
               <a:rPr sz="1500" b="1">
                 <a:solidFill>
-                  <a:srgbClr val="5EEAD4"/>
+                  <a:srgbClr val="E85A63"/>
                 </a:solidFill>
                 <a:latin typeface="Helvetica Neue"/>
               </a:rPr>
@@ -9492,7 +9492,7 @@
             <a:r>
               <a:rPr sz="3400" b="1">
                 <a:solidFill>
-                  <a:srgbClr val="D6EEF0"/>
+                  <a:srgbClr val="F7E9E3"/>
                 </a:solidFill>
                 <a:latin typeface="Helvetica Neue"/>
               </a:rPr>
@@ -9516,7 +9516,7 @@
             <a:avLst/>
           </a:prstGeom>
           <a:solidFill>
-            <a:srgbClr val="0B2026"/>
+            <a:srgbClr val="241712"/>
           </a:solidFill>
           <a:ln>
             <a:noFill/>
@@ -9570,7 +9570,7 @@
             <a:r>
               <a:rPr sz="1500">
                 <a:solidFill>
-                  <a:srgbClr val="8FB2B6"/>
+                  <a:srgbClr val="BB9A8D"/>
                 </a:solidFill>
                 <a:latin typeface="Consolas"/>
               </a:rPr>
@@ -9581,7 +9581,7 @@
             <a:r>
               <a:rPr sz="1500">
                 <a:solidFill>
-                  <a:srgbClr val="2DD4BF"/>
+                  <a:srgbClr val="FFA886"/>
                 </a:solidFill>
                 <a:latin typeface="Consolas"/>
               </a:rPr>
@@ -9592,7 +9592,7 @@
             <a:r>
               <a:rPr sz="1500">
                 <a:solidFill>
-                  <a:srgbClr val="D6EEF0"/>
+                  <a:srgbClr val="F7E9E3"/>
                 </a:solidFill>
                 <a:latin typeface="Consolas"/>
               </a:rPr>
@@ -9603,7 +9603,7 @@
             <a:r>
               <a:rPr sz="1500">
                 <a:solidFill>
-                  <a:srgbClr val="D6EEF0"/>
+                  <a:srgbClr val="F7E9E3"/>
                 </a:solidFill>
                 <a:latin typeface="Consolas"/>
               </a:rPr>
@@ -9614,7 +9614,7 @@
             <a:r>
               <a:rPr sz="1500">
                 <a:solidFill>
-                  <a:srgbClr val="8FB2B6"/>
+                  <a:srgbClr val="BB9A8D"/>
                 </a:solidFill>
                 <a:latin typeface="Consolas"/>
               </a:rPr>
@@ -9625,7 +9625,7 @@
             <a:r>
               <a:rPr sz="1500">
                 <a:solidFill>
-                  <a:srgbClr val="2DD4BF"/>
+                  <a:srgbClr val="FFA886"/>
                 </a:solidFill>
                 <a:latin typeface="Consolas"/>
               </a:rPr>
@@ -9636,7 +9636,7 @@
             <a:r>
               <a:rPr sz="1500">
                 <a:solidFill>
-                  <a:srgbClr val="D6EEF0"/>
+                  <a:srgbClr val="F7E9E3"/>
                 </a:solidFill>
                 <a:latin typeface="Consolas"/>
               </a:rPr>
@@ -9647,7 +9647,7 @@
             <a:r>
               <a:rPr sz="1500">
                 <a:solidFill>
-                  <a:srgbClr val="D6EEF0"/>
+                  <a:srgbClr val="F7E9E3"/>
                 </a:solidFill>
                 <a:latin typeface="Consolas"/>
               </a:rPr>
@@ -9658,7 +9658,7 @@
             <a:r>
               <a:rPr sz="1500">
                 <a:solidFill>
-                  <a:srgbClr val="8FB2B6"/>
+                  <a:srgbClr val="BB9A8D"/>
                 </a:solidFill>
                 <a:latin typeface="Consolas"/>
               </a:rPr>
@@ -9669,7 +9669,7 @@
             <a:r>
               <a:rPr sz="1500">
                 <a:solidFill>
-                  <a:srgbClr val="2DD4BF"/>
+                  <a:srgbClr val="FFA886"/>
                 </a:solidFill>
                 <a:latin typeface="Consolas"/>
               </a:rPr>
@@ -9704,7 +9704,7 @@
             <a:r>
               <a:rPr sz="1500" b="0">
                 <a:solidFill>
-                  <a:srgbClr val="8FB2B6"/>
+                  <a:srgbClr val="BB9A8D"/>
                 </a:solidFill>
                 <a:latin typeface="Helvetica Neue"/>
               </a:rPr>
@@ -9739,7 +9739,7 @@
             <a:r>
               <a:rPr sz="1300" b="1">
                 <a:solidFill>
-                  <a:srgbClr val="8FB2B6"/>
+                  <a:srgbClr val="BB9A8D"/>
                 </a:solidFill>
                 <a:latin typeface="Helvetica Neue"/>
               </a:rPr>
@@ -9774,7 +9774,7 @@
             <a:r>
               <a:rPr sz="1300" b="0">
                 <a:solidFill>
-                  <a:srgbClr val="8FB2B6"/>
+                  <a:srgbClr val="BB9A8D"/>
                 </a:solidFill>
                 <a:latin typeface="Helvetica Neue"/>
               </a:rPr>

</xml_diff>